<commit_message>
pptx header link removed
</commit_message>
<xml_diff>
--- a/documentation/Oréon.pptx
+++ b/documentation/Oréon.pptx
@@ -1,29 +1,29 @@
 
 <file path=ppt/presentation.xml><?xml version="1.0" encoding="utf-8"?>
-<p:presentation xmlns:a="http://schemas.openxmlformats.org/drawingml/2006/main" xmlns:r="http://schemas.openxmlformats.org/officeDocument/2006/relationships" xmlns:p="http://schemas.openxmlformats.org/presentationml/2006/main" saveSubsetFonts="1" embedTrueTypeFonts="true">
+<p:presentation xmlns:a="http://schemas.openxmlformats.org/drawingml/2006/main" xmlns:r="http://schemas.openxmlformats.org/officeDocument/2006/relationships" xmlns:p="http://schemas.openxmlformats.org/presentationml/2006/main" embedTrueTypeFonts="1" saveSubsetFonts="1">
   <p:sldMasterIdLst>
     <p:sldMasterId id="2147483648" r:id="rId1"/>
   </p:sldMasterIdLst>
   <p:sldIdLst>
-    <p:sldId id="256" r:id="rId6"/>
-    <p:sldId id="257" r:id="rId7"/>
-    <p:sldId id="258" r:id="rId8"/>
-    <p:sldId id="259" r:id="rId9"/>
-    <p:sldId id="260" r:id="rId10"/>
-    <p:sldId id="261" r:id="rId11"/>
-    <p:sldId id="262" r:id="rId12"/>
-    <p:sldId id="263" r:id="rId13"/>
+    <p:sldId id="256" r:id="rId2"/>
+    <p:sldId id="257" r:id="rId3"/>
+    <p:sldId id="258" r:id="rId4"/>
+    <p:sldId id="259" r:id="rId5"/>
+    <p:sldId id="260" r:id="rId6"/>
+    <p:sldId id="261" r:id="rId7"/>
+    <p:sldId id="262" r:id="rId8"/>
+    <p:sldId id="263" r:id="rId9"/>
   </p:sldIdLst>
   <p:sldSz cx="18288000" cy="10287000"/>
   <p:notesSz cx="6858000" cy="9144000"/>
   <p:embeddedFontLst>
     <p:embeddedFont>
-      <p:font typeface="Playfair Display" charset="1" panose="00000000000000000000"/>
-      <p:regular r:id="rId14"/>
+      <p:font typeface="Agrandir" panose="020B0604020202020204" charset="0"/>
+      <p:regular r:id="rId10"/>
     </p:embeddedFont>
     <p:embeddedFont>
-      <p:font typeface="Agrandir" charset="1" panose="00000500000000000000"/>
-      <p:regular r:id="rId15"/>
+      <p:font typeface="Playfair Display" panose="00000500000000000000" pitchFamily="2" charset="0"/>
+      <p:regular r:id="rId11"/>
     </p:embeddedFont>
   </p:embeddedFontLst>
   <p:defaultTextStyle>
@@ -121,7 +121,67 @@
       </a:defRPr>
     </a:lvl9pPr>
   </p:defaultTextStyle>
+  <p:extLst>
+    <p:ext uri="{EFAFB233-063F-42B5-8137-9DF3F51BA10A}">
+      <p15:sldGuideLst xmlns:p15="http://schemas.microsoft.com/office/powerpoint/2012/main">
+        <p15:guide id="1" orient="horz" pos="2160">
+          <p15:clr>
+            <a:srgbClr val="A4A3A4"/>
+          </p15:clr>
+        </p15:guide>
+        <p15:guide id="2" pos="2880">
+          <p15:clr>
+            <a:srgbClr val="A4A3A4"/>
+          </p15:clr>
+        </p15:guide>
+      </p15:sldGuideLst>
+    </p:ext>
+  </p:extLst>
 </p:presentation>
+</file>
+
+<file path=ppt/changesInfos/changesInfo1.xml><?xml version="1.0" encoding="utf-8"?>
+<pc:chgInfo xmlns:a="http://schemas.openxmlformats.org/drawingml/2006/main" xmlns:r="http://schemas.openxmlformats.org/officeDocument/2006/relationships" xmlns:ac="http://schemas.microsoft.com/office/drawing/2013/main/command" xmlns:pc="http://schemas.microsoft.com/office/powerpoint/2013/main/command">
+  <pc:docChgLst>
+    <pc:chgData name="Graski Lukas" userId="771b2594-553a-4abb-a0db-582d37c4f911" providerId="ADAL" clId="{98B7B874-2DD1-49E7-8CB6-28676409E9A5}"/>
+    <pc:docChg chg="custSel modSld">
+      <pc:chgData name="Graski Lukas" userId="771b2594-553a-4abb-a0db-582d37c4f911" providerId="ADAL" clId="{98B7B874-2DD1-49E7-8CB6-28676409E9A5}" dt="2026-06-16T13:03:07.956" v="1" actId="3626"/>
+      <pc:docMkLst>
+        <pc:docMk/>
+      </pc:docMkLst>
+      <pc:sldChg chg="modSp mod">
+        <pc:chgData name="Graski Lukas" userId="771b2594-553a-4abb-a0db-582d37c4f911" providerId="ADAL" clId="{98B7B874-2DD1-49E7-8CB6-28676409E9A5}" dt="2026-06-16T13:03:07.956" v="1" actId="3626"/>
+        <pc:sldMkLst>
+          <pc:docMk/>
+          <pc:sldMk cId="0" sldId="256"/>
+        </pc:sldMkLst>
+        <pc:spChg chg="mod">
+          <ac:chgData name="Graski Lukas" userId="771b2594-553a-4abb-a0db-582d37c4f911" providerId="ADAL" clId="{98B7B874-2DD1-49E7-8CB6-28676409E9A5}" dt="2026-06-16T13:03:07.956" v="1" actId="3626"/>
+          <ac:spMkLst>
+            <pc:docMk/>
+            <pc:sldMk cId="0" sldId="256"/>
+            <ac:spMk id="8" creationId="{00000000-0000-0000-0000-000000000000}"/>
+          </ac:spMkLst>
+        </pc:spChg>
+      </pc:sldChg>
+      <pc:sldChg chg="modSp mod">
+        <pc:chgData name="Graski Lukas" userId="771b2594-553a-4abb-a0db-582d37c4f911" providerId="ADAL" clId="{98B7B874-2DD1-49E7-8CB6-28676409E9A5}" dt="2026-06-16T13:02:57.887" v="0" actId="3626"/>
+        <pc:sldMkLst>
+          <pc:docMk/>
+          <pc:sldMk cId="0" sldId="257"/>
+        </pc:sldMkLst>
+        <pc:spChg chg="mod">
+          <ac:chgData name="Graski Lukas" userId="771b2594-553a-4abb-a0db-582d37c4f911" providerId="ADAL" clId="{98B7B874-2DD1-49E7-8CB6-28676409E9A5}" dt="2026-06-16T13:02:57.887" v="0" actId="3626"/>
+          <ac:spMkLst>
+            <pc:docMk/>
+            <pc:sldMk cId="0" sldId="257"/>
+            <ac:spMk id="5" creationId="{00000000-0000-0000-0000-000000000000}"/>
+          </ac:spMkLst>
+        </pc:spChg>
+      </pc:sldChg>
+    </pc:docChg>
+  </pc:docChgLst>
+</pc:chgInfo>
 </file>
 
 <file path=ppt/slideLayouts/slideLayout1.xml><?xml version="1.0" encoding="utf-8"?>
@@ -162,10 +222,9 @@
           <a:lstStyle/>
           <a:p>
             <a:r>
-              <a:rPr lang="en-US" smtClean="0"/>
+              <a:rPr lang="en-US"/>
               <a:t>Click to edit Master title style</a:t>
             </a:r>
-            <a:endParaRPr lang="en-US"/>
           </a:p>
         </p:txBody>
       </p:sp>
@@ -281,10 +340,9 @@
           </a:lstStyle>
           <a:p>
             <a:r>
-              <a:rPr lang="en-US" smtClean="0"/>
+              <a:rPr lang="en-US"/>
               <a:t>Click to edit Master subtitle style</a:t>
             </a:r>
-            <a:endParaRPr lang="en-US"/>
           </a:p>
         </p:txBody>
       </p:sp>
@@ -306,7 +364,7 @@
             <a:fld id="{1D8BD707-D9CF-40AE-B4C6-C98DA3205C09}" type="datetimeFigureOut">
               <a:rPr lang="en-US" smtClean="0"/>
               <a:pPr/>
-              <a:t>8/1/2011</a:t>
+              <a:t>6/16/2026</a:t>
             </a:fld>
             <a:endParaRPr lang="en-US"/>
           </a:p>
@@ -349,7 +407,7 @@
             <a:fld id="{B6F15528-21DE-4FAA-801E-634DDDAF4B2B}" type="slidenum">
               <a:rPr lang="en-US" smtClean="0"/>
               <a:pPr/>
-              <a:t>‹#›</a:t>
+              <a:t>‹Nr.›</a:t>
             </a:fld>
             <a:endParaRPr lang="en-US"/>
           </a:p>
@@ -396,10 +454,9 @@
           <a:lstStyle/>
           <a:p>
             <a:r>
-              <a:rPr lang="en-US" smtClean="0"/>
+              <a:rPr lang="en-US"/>
               <a:t>Click to edit Master title style</a:t>
             </a:r>
-            <a:endParaRPr lang="en-US"/>
           </a:p>
         </p:txBody>
       </p:sp>
@@ -420,38 +477,37 @@
           <a:p>
             <a:pPr lvl="0"/>
             <a:r>
-              <a:rPr lang="en-US" smtClean="0"/>
+              <a:rPr lang="en-US"/>
               <a:t>Click to edit Master text styles</a:t>
             </a:r>
           </a:p>
           <a:p>
             <a:pPr lvl="1"/>
             <a:r>
-              <a:rPr lang="en-US" smtClean="0"/>
+              <a:rPr lang="en-US"/>
               <a:t>Second level</a:t>
             </a:r>
           </a:p>
           <a:p>
             <a:pPr lvl="2"/>
             <a:r>
-              <a:rPr lang="en-US" smtClean="0"/>
+              <a:rPr lang="en-US"/>
               <a:t>Third level</a:t>
             </a:r>
           </a:p>
           <a:p>
             <a:pPr lvl="3"/>
             <a:r>
-              <a:rPr lang="en-US" smtClean="0"/>
+              <a:rPr lang="en-US"/>
               <a:t>Fourth level</a:t>
             </a:r>
           </a:p>
           <a:p>
             <a:pPr lvl="4"/>
             <a:r>
-              <a:rPr lang="en-US" smtClean="0"/>
+              <a:rPr lang="en-US"/>
               <a:t>Fifth level</a:t>
             </a:r>
-            <a:endParaRPr lang="en-US"/>
           </a:p>
         </p:txBody>
       </p:sp>
@@ -473,7 +529,7 @@
             <a:fld id="{1D8BD707-D9CF-40AE-B4C6-C98DA3205C09}" type="datetimeFigureOut">
               <a:rPr lang="en-US" smtClean="0"/>
               <a:pPr/>
-              <a:t>8/1/2011</a:t>
+              <a:t>6/16/2026</a:t>
             </a:fld>
             <a:endParaRPr lang="en-US"/>
           </a:p>
@@ -516,7 +572,7 @@
             <a:fld id="{B6F15528-21DE-4FAA-801E-634DDDAF4B2B}" type="slidenum">
               <a:rPr lang="en-US" smtClean="0"/>
               <a:pPr/>
-              <a:t>‹#›</a:t>
+              <a:t>‹Nr.›</a:t>
             </a:fld>
             <a:endParaRPr lang="en-US"/>
           </a:p>
@@ -568,10 +624,9 @@
           <a:lstStyle/>
           <a:p>
             <a:r>
-              <a:rPr lang="en-US" smtClean="0"/>
+              <a:rPr lang="en-US"/>
               <a:t>Click to edit Master title style</a:t>
             </a:r>
-            <a:endParaRPr lang="en-US"/>
           </a:p>
         </p:txBody>
       </p:sp>
@@ -597,38 +652,37 @@
           <a:p>
             <a:pPr lvl="0"/>
             <a:r>
-              <a:rPr lang="en-US" smtClean="0"/>
+              <a:rPr lang="en-US"/>
               <a:t>Click to edit Master text styles</a:t>
             </a:r>
           </a:p>
           <a:p>
             <a:pPr lvl="1"/>
             <a:r>
-              <a:rPr lang="en-US" smtClean="0"/>
+              <a:rPr lang="en-US"/>
               <a:t>Second level</a:t>
             </a:r>
           </a:p>
           <a:p>
             <a:pPr lvl="2"/>
             <a:r>
-              <a:rPr lang="en-US" smtClean="0"/>
+              <a:rPr lang="en-US"/>
               <a:t>Third level</a:t>
             </a:r>
           </a:p>
           <a:p>
             <a:pPr lvl="3"/>
             <a:r>
-              <a:rPr lang="en-US" smtClean="0"/>
+              <a:rPr lang="en-US"/>
               <a:t>Fourth level</a:t>
             </a:r>
           </a:p>
           <a:p>
             <a:pPr lvl="4"/>
             <a:r>
-              <a:rPr lang="en-US" smtClean="0"/>
+              <a:rPr lang="en-US"/>
               <a:t>Fifth level</a:t>
             </a:r>
-            <a:endParaRPr lang="en-US"/>
           </a:p>
         </p:txBody>
       </p:sp>
@@ -650,7 +704,7 @@
             <a:fld id="{1D8BD707-D9CF-40AE-B4C6-C98DA3205C09}" type="datetimeFigureOut">
               <a:rPr lang="en-US" smtClean="0"/>
               <a:pPr/>
-              <a:t>8/1/2011</a:t>
+              <a:t>6/16/2026</a:t>
             </a:fld>
             <a:endParaRPr lang="en-US"/>
           </a:p>
@@ -693,7 +747,7 @@
             <a:fld id="{B6F15528-21DE-4FAA-801E-634DDDAF4B2B}" type="slidenum">
               <a:rPr lang="en-US" smtClean="0"/>
               <a:pPr/>
-              <a:t>‹#›</a:t>
+              <a:t>‹Nr.›</a:t>
             </a:fld>
             <a:endParaRPr lang="en-US"/>
           </a:p>
@@ -740,10 +794,9 @@
           <a:lstStyle/>
           <a:p>
             <a:r>
-              <a:rPr lang="en-US" smtClean="0"/>
+              <a:rPr lang="en-US"/>
               <a:t>Click to edit Master title style</a:t>
             </a:r>
-            <a:endParaRPr lang="en-US"/>
           </a:p>
         </p:txBody>
       </p:sp>
@@ -764,38 +817,37 @@
           <a:p>
             <a:pPr lvl="0"/>
             <a:r>
-              <a:rPr lang="en-US" smtClean="0"/>
+              <a:rPr lang="en-US"/>
               <a:t>Click to edit Master text styles</a:t>
             </a:r>
           </a:p>
           <a:p>
             <a:pPr lvl="1"/>
             <a:r>
-              <a:rPr lang="en-US" smtClean="0"/>
+              <a:rPr lang="en-US"/>
               <a:t>Second level</a:t>
             </a:r>
           </a:p>
           <a:p>
             <a:pPr lvl="2"/>
             <a:r>
-              <a:rPr lang="en-US" smtClean="0"/>
+              <a:rPr lang="en-US"/>
               <a:t>Third level</a:t>
             </a:r>
           </a:p>
           <a:p>
             <a:pPr lvl="3"/>
             <a:r>
-              <a:rPr lang="en-US" smtClean="0"/>
+              <a:rPr lang="en-US"/>
               <a:t>Fourth level</a:t>
             </a:r>
           </a:p>
           <a:p>
             <a:pPr lvl="4"/>
             <a:r>
-              <a:rPr lang="en-US" smtClean="0"/>
+              <a:rPr lang="en-US"/>
               <a:t>Fifth level</a:t>
             </a:r>
-            <a:endParaRPr lang="en-US"/>
           </a:p>
         </p:txBody>
       </p:sp>
@@ -817,7 +869,7 @@
             <a:fld id="{1D8BD707-D9CF-40AE-B4C6-C98DA3205C09}" type="datetimeFigureOut">
               <a:rPr lang="en-US" smtClean="0"/>
               <a:pPr/>
-              <a:t>8/1/2011</a:t>
+              <a:t>6/16/2026</a:t>
             </a:fld>
             <a:endParaRPr lang="en-US"/>
           </a:p>
@@ -860,7 +912,7 @@
             <a:fld id="{B6F15528-21DE-4FAA-801E-634DDDAF4B2B}" type="slidenum">
               <a:rPr lang="en-US" smtClean="0"/>
               <a:pPr/>
-              <a:t>‹#›</a:t>
+              <a:t>‹Nr.›</a:t>
             </a:fld>
             <a:endParaRPr lang="en-US"/>
           </a:p>
@@ -916,10 +968,9 @@
           </a:lstStyle>
           <a:p>
             <a:r>
-              <a:rPr lang="en-US" smtClean="0"/>
+              <a:rPr lang="en-US"/>
               <a:t>Click to edit Master title style</a:t>
             </a:r>
-            <a:endParaRPr lang="en-US"/>
           </a:p>
         </p:txBody>
       </p:sp>
@@ -1036,7 +1087,7 @@
           <a:p>
             <a:pPr lvl="0"/>
             <a:r>
-              <a:rPr lang="en-US" smtClean="0"/>
+              <a:rPr lang="en-US"/>
               <a:t>Click to edit Master text styles</a:t>
             </a:r>
           </a:p>
@@ -1060,7 +1111,7 @@
             <a:fld id="{1D8BD707-D9CF-40AE-B4C6-C98DA3205C09}" type="datetimeFigureOut">
               <a:rPr lang="en-US" smtClean="0"/>
               <a:pPr/>
-              <a:t>8/1/2011</a:t>
+              <a:t>6/16/2026</a:t>
             </a:fld>
             <a:endParaRPr lang="en-US"/>
           </a:p>
@@ -1103,7 +1154,7 @@
             <a:fld id="{B6F15528-21DE-4FAA-801E-634DDDAF4B2B}" type="slidenum">
               <a:rPr lang="en-US" smtClean="0"/>
               <a:pPr/>
-              <a:t>‹#›</a:t>
+              <a:t>‹Nr.›</a:t>
             </a:fld>
             <a:endParaRPr lang="en-US"/>
           </a:p>
@@ -1150,10 +1201,9 @@
           <a:lstStyle/>
           <a:p>
             <a:r>
-              <a:rPr lang="en-US" smtClean="0"/>
+              <a:rPr lang="en-US"/>
               <a:t>Click to edit Master title style</a:t>
             </a:r>
-            <a:endParaRPr lang="en-US"/>
           </a:p>
         </p:txBody>
       </p:sp>
@@ -1207,38 +1257,37 @@
           <a:p>
             <a:pPr lvl="0"/>
             <a:r>
-              <a:rPr lang="en-US" smtClean="0"/>
+              <a:rPr lang="en-US"/>
               <a:t>Click to edit Master text styles</a:t>
             </a:r>
           </a:p>
           <a:p>
             <a:pPr lvl="1"/>
             <a:r>
-              <a:rPr lang="en-US" smtClean="0"/>
+              <a:rPr lang="en-US"/>
               <a:t>Second level</a:t>
             </a:r>
           </a:p>
           <a:p>
             <a:pPr lvl="2"/>
             <a:r>
-              <a:rPr lang="en-US" smtClean="0"/>
+              <a:rPr lang="en-US"/>
               <a:t>Third level</a:t>
             </a:r>
           </a:p>
           <a:p>
             <a:pPr lvl="3"/>
             <a:r>
-              <a:rPr lang="en-US" smtClean="0"/>
+              <a:rPr lang="en-US"/>
               <a:t>Fourth level</a:t>
             </a:r>
           </a:p>
           <a:p>
             <a:pPr lvl="4"/>
             <a:r>
-              <a:rPr lang="en-US" smtClean="0"/>
+              <a:rPr lang="en-US"/>
               <a:t>Fifth level</a:t>
             </a:r>
-            <a:endParaRPr lang="en-US"/>
           </a:p>
         </p:txBody>
       </p:sp>
@@ -1292,38 +1341,37 @@
           <a:p>
             <a:pPr lvl="0"/>
             <a:r>
-              <a:rPr lang="en-US" smtClean="0"/>
+              <a:rPr lang="en-US"/>
               <a:t>Click to edit Master text styles</a:t>
             </a:r>
           </a:p>
           <a:p>
             <a:pPr lvl="1"/>
             <a:r>
-              <a:rPr lang="en-US" smtClean="0"/>
+              <a:rPr lang="en-US"/>
               <a:t>Second level</a:t>
             </a:r>
           </a:p>
           <a:p>
             <a:pPr lvl="2"/>
             <a:r>
-              <a:rPr lang="en-US" smtClean="0"/>
+              <a:rPr lang="en-US"/>
               <a:t>Third level</a:t>
             </a:r>
           </a:p>
           <a:p>
             <a:pPr lvl="3"/>
             <a:r>
-              <a:rPr lang="en-US" smtClean="0"/>
+              <a:rPr lang="en-US"/>
               <a:t>Fourth level</a:t>
             </a:r>
           </a:p>
           <a:p>
             <a:pPr lvl="4"/>
             <a:r>
-              <a:rPr lang="en-US" smtClean="0"/>
+              <a:rPr lang="en-US"/>
               <a:t>Fifth level</a:t>
             </a:r>
-            <a:endParaRPr lang="en-US"/>
           </a:p>
         </p:txBody>
       </p:sp>
@@ -1345,7 +1393,7 @@
             <a:fld id="{1D8BD707-D9CF-40AE-B4C6-C98DA3205C09}" type="datetimeFigureOut">
               <a:rPr lang="en-US" smtClean="0"/>
               <a:pPr/>
-              <a:t>8/1/2011</a:t>
+              <a:t>6/16/2026</a:t>
             </a:fld>
             <a:endParaRPr lang="en-US"/>
           </a:p>
@@ -1388,7 +1436,7 @@
             <a:fld id="{B6F15528-21DE-4FAA-801E-634DDDAF4B2B}" type="slidenum">
               <a:rPr lang="en-US" smtClean="0"/>
               <a:pPr/>
-              <a:t>‹#›</a:t>
+              <a:t>‹Nr.›</a:t>
             </a:fld>
             <a:endParaRPr lang="en-US"/>
           </a:p>
@@ -1439,10 +1487,9 @@
           </a:lstStyle>
           <a:p>
             <a:r>
-              <a:rPr lang="en-US" smtClean="0"/>
+              <a:rPr lang="en-US"/>
               <a:t>Click to edit Master title style</a:t>
             </a:r>
-            <a:endParaRPr lang="en-US"/>
           </a:p>
         </p:txBody>
       </p:sp>
@@ -1505,7 +1552,7 @@
           <a:p>
             <a:pPr lvl="0"/>
             <a:r>
-              <a:rPr lang="en-US" smtClean="0"/>
+              <a:rPr lang="en-US"/>
               <a:t>Click to edit Master text styles</a:t>
             </a:r>
           </a:p>
@@ -1561,38 +1608,37 @@
           <a:p>
             <a:pPr lvl="0"/>
             <a:r>
-              <a:rPr lang="en-US" smtClean="0"/>
+              <a:rPr lang="en-US"/>
               <a:t>Click to edit Master text styles</a:t>
             </a:r>
           </a:p>
           <a:p>
             <a:pPr lvl="1"/>
             <a:r>
-              <a:rPr lang="en-US" smtClean="0"/>
+              <a:rPr lang="en-US"/>
               <a:t>Second level</a:t>
             </a:r>
           </a:p>
           <a:p>
             <a:pPr lvl="2"/>
             <a:r>
-              <a:rPr lang="en-US" smtClean="0"/>
+              <a:rPr lang="en-US"/>
               <a:t>Third level</a:t>
             </a:r>
           </a:p>
           <a:p>
             <a:pPr lvl="3"/>
             <a:r>
-              <a:rPr lang="en-US" smtClean="0"/>
+              <a:rPr lang="en-US"/>
               <a:t>Fourth level</a:t>
             </a:r>
           </a:p>
           <a:p>
             <a:pPr lvl="4"/>
             <a:r>
-              <a:rPr lang="en-US" smtClean="0"/>
+              <a:rPr lang="en-US"/>
               <a:t>Fifth level</a:t>
             </a:r>
-            <a:endParaRPr lang="en-US"/>
           </a:p>
         </p:txBody>
       </p:sp>
@@ -1655,7 +1701,7 @@
           <a:p>
             <a:pPr lvl="0"/>
             <a:r>
-              <a:rPr lang="en-US" smtClean="0"/>
+              <a:rPr lang="en-US"/>
               <a:t>Click to edit Master text styles</a:t>
             </a:r>
           </a:p>
@@ -1711,38 +1757,37 @@
           <a:p>
             <a:pPr lvl="0"/>
             <a:r>
-              <a:rPr lang="en-US" smtClean="0"/>
+              <a:rPr lang="en-US"/>
               <a:t>Click to edit Master text styles</a:t>
             </a:r>
           </a:p>
           <a:p>
             <a:pPr lvl="1"/>
             <a:r>
-              <a:rPr lang="en-US" smtClean="0"/>
+              <a:rPr lang="en-US"/>
               <a:t>Second level</a:t>
             </a:r>
           </a:p>
           <a:p>
             <a:pPr lvl="2"/>
             <a:r>
-              <a:rPr lang="en-US" smtClean="0"/>
+              <a:rPr lang="en-US"/>
               <a:t>Third level</a:t>
             </a:r>
           </a:p>
           <a:p>
             <a:pPr lvl="3"/>
             <a:r>
-              <a:rPr lang="en-US" smtClean="0"/>
+              <a:rPr lang="en-US"/>
               <a:t>Fourth level</a:t>
             </a:r>
           </a:p>
           <a:p>
             <a:pPr lvl="4"/>
             <a:r>
-              <a:rPr lang="en-US" smtClean="0"/>
+              <a:rPr lang="en-US"/>
               <a:t>Fifth level</a:t>
             </a:r>
-            <a:endParaRPr lang="en-US"/>
           </a:p>
         </p:txBody>
       </p:sp>
@@ -1764,7 +1809,7 @@
             <a:fld id="{1D8BD707-D9CF-40AE-B4C6-C98DA3205C09}" type="datetimeFigureOut">
               <a:rPr lang="en-US" smtClean="0"/>
               <a:pPr/>
-              <a:t>8/1/2011</a:t>
+              <a:t>6/16/2026</a:t>
             </a:fld>
             <a:endParaRPr lang="en-US"/>
           </a:p>
@@ -1807,7 +1852,7 @@
             <a:fld id="{B6F15528-21DE-4FAA-801E-634DDDAF4B2B}" type="slidenum">
               <a:rPr lang="en-US" smtClean="0"/>
               <a:pPr/>
-              <a:t>‹#›</a:t>
+              <a:t>‹Nr.›</a:t>
             </a:fld>
             <a:endParaRPr lang="en-US"/>
           </a:p>
@@ -1854,10 +1899,9 @@
           <a:lstStyle/>
           <a:p>
             <a:r>
-              <a:rPr lang="en-US" smtClean="0"/>
+              <a:rPr lang="en-US"/>
               <a:t>Click to edit Master title style</a:t>
             </a:r>
-            <a:endParaRPr lang="en-US"/>
           </a:p>
         </p:txBody>
       </p:sp>
@@ -1879,7 +1923,7 @@
             <a:fld id="{1D8BD707-D9CF-40AE-B4C6-C98DA3205C09}" type="datetimeFigureOut">
               <a:rPr lang="en-US" smtClean="0"/>
               <a:pPr/>
-              <a:t>8/1/2011</a:t>
+              <a:t>6/16/2026</a:t>
             </a:fld>
             <a:endParaRPr lang="en-US"/>
           </a:p>
@@ -1922,7 +1966,7 @@
             <a:fld id="{B6F15528-21DE-4FAA-801E-634DDDAF4B2B}" type="slidenum">
               <a:rPr lang="en-US" smtClean="0"/>
               <a:pPr/>
-              <a:t>‹#›</a:t>
+              <a:t>‹Nr.›</a:t>
             </a:fld>
             <a:endParaRPr lang="en-US"/>
           </a:p>
@@ -1971,7 +2015,7 @@
             <a:fld id="{1D8BD707-D9CF-40AE-B4C6-C98DA3205C09}" type="datetimeFigureOut">
               <a:rPr lang="en-US" smtClean="0"/>
               <a:pPr/>
-              <a:t>8/1/2011</a:t>
+              <a:t>6/16/2026</a:t>
             </a:fld>
             <a:endParaRPr lang="en-US"/>
           </a:p>
@@ -2014,7 +2058,7 @@
             <a:fld id="{B6F15528-21DE-4FAA-801E-634DDDAF4B2B}" type="slidenum">
               <a:rPr lang="en-US" smtClean="0"/>
               <a:pPr/>
-              <a:t>‹#›</a:t>
+              <a:t>‹Nr.›</a:t>
             </a:fld>
             <a:endParaRPr lang="en-US"/>
           </a:p>
@@ -2070,10 +2114,9 @@
           </a:lstStyle>
           <a:p>
             <a:r>
-              <a:rPr lang="en-US" smtClean="0"/>
+              <a:rPr lang="en-US"/>
               <a:t>Click to edit Master title style</a:t>
             </a:r>
-            <a:endParaRPr lang="en-US"/>
           </a:p>
         </p:txBody>
       </p:sp>
@@ -2127,38 +2170,37 @@
           <a:p>
             <a:pPr lvl="0"/>
             <a:r>
-              <a:rPr lang="en-US" smtClean="0"/>
+              <a:rPr lang="en-US"/>
               <a:t>Click to edit Master text styles</a:t>
             </a:r>
           </a:p>
           <a:p>
             <a:pPr lvl="1"/>
             <a:r>
-              <a:rPr lang="en-US" smtClean="0"/>
+              <a:rPr lang="en-US"/>
               <a:t>Second level</a:t>
             </a:r>
           </a:p>
           <a:p>
             <a:pPr lvl="2"/>
             <a:r>
-              <a:rPr lang="en-US" smtClean="0"/>
+              <a:rPr lang="en-US"/>
               <a:t>Third level</a:t>
             </a:r>
           </a:p>
           <a:p>
             <a:pPr lvl="3"/>
             <a:r>
-              <a:rPr lang="en-US" smtClean="0"/>
+              <a:rPr lang="en-US"/>
               <a:t>Fourth level</a:t>
             </a:r>
           </a:p>
           <a:p>
             <a:pPr lvl="4"/>
             <a:r>
-              <a:rPr lang="en-US" smtClean="0"/>
+              <a:rPr lang="en-US"/>
               <a:t>Fifth level</a:t>
             </a:r>
-            <a:endParaRPr lang="en-US"/>
           </a:p>
         </p:txBody>
       </p:sp>
@@ -2221,7 +2263,7 @@
           <a:p>
             <a:pPr lvl="0"/>
             <a:r>
-              <a:rPr lang="en-US" smtClean="0"/>
+              <a:rPr lang="en-US"/>
               <a:t>Click to edit Master text styles</a:t>
             </a:r>
           </a:p>
@@ -2245,7 +2287,7 @@
             <a:fld id="{1D8BD707-D9CF-40AE-B4C6-C98DA3205C09}" type="datetimeFigureOut">
               <a:rPr lang="en-US" smtClean="0"/>
               <a:pPr/>
-              <a:t>8/1/2011</a:t>
+              <a:t>6/16/2026</a:t>
             </a:fld>
             <a:endParaRPr lang="en-US"/>
           </a:p>
@@ -2288,7 +2330,7 @@
             <a:fld id="{B6F15528-21DE-4FAA-801E-634DDDAF4B2B}" type="slidenum">
               <a:rPr lang="en-US" smtClean="0"/>
               <a:pPr/>
-              <a:t>‹#›</a:t>
+              <a:t>‹Nr.›</a:t>
             </a:fld>
             <a:endParaRPr lang="en-US"/>
           </a:p>
@@ -2344,10 +2386,9 @@
           </a:lstStyle>
           <a:p>
             <a:r>
-              <a:rPr lang="en-US" smtClean="0"/>
+              <a:rPr lang="en-US"/>
               <a:t>Click to edit Master title style</a:t>
             </a:r>
-            <a:endParaRPr lang="en-US"/>
           </a:p>
         </p:txBody>
       </p:sp>
@@ -2471,7 +2512,7 @@
           <a:p>
             <a:pPr lvl="0"/>
             <a:r>
-              <a:rPr lang="en-US" smtClean="0"/>
+              <a:rPr lang="en-US"/>
               <a:t>Click to edit Master text styles</a:t>
             </a:r>
           </a:p>
@@ -2495,7 +2536,7 @@
             <a:fld id="{1D8BD707-D9CF-40AE-B4C6-C98DA3205C09}" type="datetimeFigureOut">
               <a:rPr lang="en-US" smtClean="0"/>
               <a:pPr/>
-              <a:t>8/1/2011</a:t>
+              <a:t>6/16/2026</a:t>
             </a:fld>
             <a:endParaRPr lang="en-US"/>
           </a:p>
@@ -2538,7 +2579,7 @@
             <a:fld id="{B6F15528-21DE-4FAA-801E-634DDDAF4B2B}" type="slidenum">
               <a:rPr lang="en-US" smtClean="0"/>
               <a:pPr/>
-              <a:t>‹#›</a:t>
+              <a:t>‹Nr.›</a:t>
             </a:fld>
             <a:endParaRPr lang="en-US"/>
           </a:p>
@@ -2600,10 +2641,9 @@
           <a:lstStyle/>
           <a:p>
             <a:r>
-              <a:rPr lang="en-US" smtClean="0"/>
+              <a:rPr lang="en-US"/>
               <a:t>Click to edit Master title style</a:t>
             </a:r>
-            <a:endParaRPr lang="en-US"/>
           </a:p>
         </p:txBody>
       </p:sp>
@@ -2634,38 +2674,37 @@
           <a:p>
             <a:pPr lvl="0"/>
             <a:r>
-              <a:rPr lang="en-US" smtClean="0"/>
+              <a:rPr lang="en-US"/>
               <a:t>Click to edit Master text styles</a:t>
             </a:r>
           </a:p>
           <a:p>
             <a:pPr lvl="1"/>
             <a:r>
-              <a:rPr lang="en-US" smtClean="0"/>
+              <a:rPr lang="en-US"/>
               <a:t>Second level</a:t>
             </a:r>
           </a:p>
           <a:p>
             <a:pPr lvl="2"/>
             <a:r>
-              <a:rPr lang="en-US" smtClean="0"/>
+              <a:rPr lang="en-US"/>
               <a:t>Third level</a:t>
             </a:r>
           </a:p>
           <a:p>
             <a:pPr lvl="3"/>
             <a:r>
-              <a:rPr lang="en-US" smtClean="0"/>
+              <a:rPr lang="en-US"/>
               <a:t>Fourth level</a:t>
             </a:r>
           </a:p>
           <a:p>
             <a:pPr lvl="4"/>
             <a:r>
-              <a:rPr lang="en-US" smtClean="0"/>
+              <a:rPr lang="en-US"/>
               <a:t>Fifth level</a:t>
             </a:r>
-            <a:endParaRPr lang="en-US"/>
           </a:p>
         </p:txBody>
       </p:sp>
@@ -2705,7 +2744,7 @@
             <a:fld id="{1D8BD707-D9CF-40AE-B4C6-C98DA3205C09}" type="datetimeFigureOut">
               <a:rPr lang="en-US" smtClean="0"/>
               <a:pPr/>
-              <a:t>8/1/2011</a:t>
+              <a:t>6/16/2026</a:t>
             </a:fld>
             <a:endParaRPr lang="en-US"/>
           </a:p>
@@ -2784,7 +2823,7 @@
             <a:fld id="{B6F15528-21DE-4FAA-801E-634DDDAF4B2B}" type="slidenum">
               <a:rPr lang="en-US" smtClean="0"/>
               <a:pPr/>
-              <a:t>‹#›</a:t>
+              <a:t>‹Nr.›</a:t>
             </a:fld>
             <a:endParaRPr lang="en-US"/>
           </a:p>
@@ -3060,13 +3099,14 @@
 </file>
 
 <file path=ppt/slides/slide1.xml><?xml version="1.0" encoding="utf-8"?>
-<p:sld xmlns:p="http://schemas.openxmlformats.org/presentationml/2006/main" xmlns:a="http://schemas.openxmlformats.org/drawingml/2006/main" xmlns:r="http://schemas.openxmlformats.org/officeDocument/2006/relationships">
+<p:sld xmlns:a="http://schemas.openxmlformats.org/drawingml/2006/main" xmlns:r="http://schemas.openxmlformats.org/officeDocument/2006/relationships" xmlns:p="http://schemas.openxmlformats.org/presentationml/2006/main">
   <p:cSld>
     <p:bg>
       <p:bgPr>
         <a:solidFill>
           <a:srgbClr val="F6F3E4"/>
         </a:solidFill>
+        <a:effectLst/>
       </p:bgPr>
     </p:bg>
     <p:spTree>
@@ -3085,12 +3125,12 @@
       </p:grpSpPr>
       <p:grpSp>
         <p:nvGrpSpPr>
-          <p:cNvPr name="Group 2" id="2"/>
+          <p:cNvPr id="2" name="Group 2"/>
           <p:cNvGrpSpPr/>
           <p:nvPr/>
         </p:nvGrpSpPr>
         <p:grpSpPr>
-          <a:xfrm rot="0">
+          <a:xfrm>
             <a:off x="11995116" y="-6819685"/>
             <a:ext cx="10124574" cy="10124574"/>
             <a:chOff x="0" y="0"/>
@@ -3099,12 +3139,12 @@
         </p:grpSpPr>
         <p:sp>
           <p:nvSpPr>
-            <p:cNvPr name="Freeform 3" id="3"/>
+            <p:cNvPr id="3" name="Freeform 3"/>
             <p:cNvSpPr/>
             <p:nvPr/>
           </p:nvSpPr>
           <p:spPr>
-            <a:xfrm flipH="false" flipV="false" rot="0">
+            <a:xfrm>
               <a:off x="0" y="0"/>
               <a:ext cx="812800" cy="812800"/>
             </a:xfrm>
@@ -3113,9 +3153,9 @@
               <a:gdLst/>
               <a:ahLst/>
               <a:cxnLst/>
-              <a:rect r="r" b="b" t="t" l="l"/>
+              <a:rect l="l" t="t" r="r" b="b"/>
               <a:pathLst>
-                <a:path h="812800" w="812800">
+                <a:path w="812800" h="812800">
                   <a:moveTo>
                     <a:pt x="406400" y="0"/>
                   </a:moveTo>
@@ -3151,11 +3191,18 @@
               <a:miter/>
             </a:ln>
           </p:spPr>
+          <p:txBody>
+            <a:bodyPr/>
+            <a:lstStyle/>
+            <a:p>
+              <a:endParaRPr lang="en-US"/>
+            </a:p>
+          </p:txBody>
         </p:sp>
         <p:sp>
           <p:nvSpPr>
-            <p:cNvPr name="TextBox 4" id="4"/>
-            <p:cNvSpPr txBox="true"/>
+            <p:cNvPr id="4" name="TextBox 4"/>
+            <p:cNvSpPr txBox="1"/>
             <p:nvPr/>
           </p:nvSpPr>
           <p:spPr>
@@ -3168,7 +3215,7 @@
             </a:prstGeom>
           </p:spPr>
           <p:txBody>
-            <a:bodyPr anchor="ctr" rtlCol="false" tIns="50800" lIns="50800" bIns="50800" rIns="50800"/>
+            <a:bodyPr lIns="50800" tIns="50800" rIns="50800" bIns="50800" rtlCol="0" anchor="ctr"/>
             <a:lstStyle/>
             <a:p>
               <a:pPr algn="ctr">
@@ -3176,18 +3223,19 @@
                   <a:spcPts val="2659"/>
                 </a:lnSpc>
               </a:pPr>
+              <a:endParaRPr/>
             </a:p>
           </p:txBody>
         </p:sp>
       </p:grpSp>
       <p:grpSp>
         <p:nvGrpSpPr>
-          <p:cNvPr name="Group 5" id="5"/>
+          <p:cNvPr id="5" name="Group 5"/>
           <p:cNvGrpSpPr/>
           <p:nvPr/>
         </p:nvGrpSpPr>
         <p:grpSpPr>
-          <a:xfrm rot="0">
+          <a:xfrm>
             <a:off x="-3831690" y="6982111"/>
             <a:ext cx="10124574" cy="10124574"/>
             <a:chOff x="0" y="0"/>
@@ -3196,12 +3244,12 @@
         </p:grpSpPr>
         <p:sp>
           <p:nvSpPr>
-            <p:cNvPr name="Freeform 6" id="6"/>
+            <p:cNvPr id="6" name="Freeform 6"/>
             <p:cNvSpPr/>
             <p:nvPr/>
           </p:nvSpPr>
           <p:spPr>
-            <a:xfrm flipH="false" flipV="false" rot="0">
+            <a:xfrm>
               <a:off x="0" y="0"/>
               <a:ext cx="812800" cy="812800"/>
             </a:xfrm>
@@ -3210,9 +3258,9 @@
               <a:gdLst/>
               <a:ahLst/>
               <a:cxnLst/>
-              <a:rect r="r" b="b" t="t" l="l"/>
+              <a:rect l="l" t="t" r="r" b="b"/>
               <a:pathLst>
-                <a:path h="812800" w="812800">
+                <a:path w="812800" h="812800">
                   <a:moveTo>
                     <a:pt x="406400" y="0"/>
                   </a:moveTo>
@@ -3248,11 +3296,18 @@
               <a:miter/>
             </a:ln>
           </p:spPr>
+          <p:txBody>
+            <a:bodyPr/>
+            <a:lstStyle/>
+            <a:p>
+              <a:endParaRPr lang="en-US"/>
+            </a:p>
+          </p:txBody>
         </p:sp>
         <p:sp>
           <p:nvSpPr>
-            <p:cNvPr name="TextBox 7" id="7"/>
-            <p:cNvSpPr txBox="true"/>
+            <p:cNvPr id="7" name="TextBox 7"/>
+            <p:cNvSpPr txBox="1"/>
             <p:nvPr/>
           </p:nvSpPr>
           <p:spPr>
@@ -3265,7 +3320,7 @@
             </a:prstGeom>
           </p:spPr>
           <p:txBody>
-            <a:bodyPr anchor="ctr" rtlCol="false" tIns="50800" lIns="50800" bIns="50800" rIns="50800"/>
+            <a:bodyPr lIns="50800" tIns="50800" rIns="50800" bIns="50800" rtlCol="0" anchor="ctr"/>
             <a:lstStyle/>
             <a:p>
               <a:pPr algn="ctr">
@@ -3273,18 +3328,19 @@
                   <a:spcPts val="2659"/>
                 </a:lnSpc>
               </a:pPr>
+              <a:endParaRPr/>
             </a:p>
           </p:txBody>
         </p:sp>
       </p:grpSp>
       <p:sp>
         <p:nvSpPr>
-          <p:cNvPr name="TextBox 8" id="8"/>
-          <p:cNvSpPr txBox="true"/>
+          <p:cNvPr id="8" name="TextBox 8"/>
+          <p:cNvSpPr txBox="1"/>
           <p:nvPr/>
         </p:nvSpPr>
         <p:spPr>
-          <a:xfrm rot="0">
+          <a:xfrm>
             <a:off x="2121685" y="3307740"/>
             <a:ext cx="14044630" cy="3219450"/>
           </a:xfrm>
@@ -3293,7 +3349,7 @@
           </a:prstGeom>
         </p:spPr>
         <p:txBody>
-          <a:bodyPr anchor="t" rtlCol="false" tIns="0" lIns="0" bIns="0" rIns="0">
+          <a:bodyPr lIns="0" tIns="0" rIns="0" bIns="0" rtlCol="0" anchor="t">
             <a:spAutoFit/>
           </a:bodyPr>
           <a:lstStyle/>
@@ -3307,7 +3363,7 @@
               </a:spcBef>
             </a:pPr>
             <a:r>
-              <a:rPr lang="en-US" sz="21156">
+              <a:rPr lang="en-US" sz="21156" dirty="0" err="1">
                 <a:solidFill>
                   <a:srgbClr val="717236"/>
                 </a:solidFill>
@@ -3315,34 +3371,30 @@
                 <a:ea typeface="Playfair Display"/>
                 <a:cs typeface="Playfair Display"/>
                 <a:sym typeface="Playfair Display"/>
-                <a:hlinkClick r:id="rId2" tooltip="http://localhost:8080/db_testing/2526-3bhitm-sommerprojekt-l-graski/project/index.html"/>
               </a:rPr>
-              <a:t>O</a:t>
-            </a:r>
-            <a:r>
-              <a:rPr lang="en-US" sz="21156">
-                <a:solidFill>
-                  <a:srgbClr val="717236"/>
-                </a:solidFill>
-                <a:latin typeface="Playfair Display"/>
-                <a:ea typeface="Playfair Display"/>
-                <a:cs typeface="Playfair Display"/>
-                <a:sym typeface="Playfair Display"/>
-                <a:hlinkClick r:id="rId3" tooltip="http://localhost:8080/db_testing/2526-3bhitm-sommerprojekt-l-graski/project/index.html"/>
-              </a:rPr>
-              <a:t>réon</a:t>
-            </a:r>
-          </a:p>
-        </p:txBody>
-      </p:sp>
-      <p:sp>
-        <p:nvSpPr>
-          <p:cNvPr name="Freeform 9" id="9"/>
+              <a:t>Oréon</a:t>
+            </a:r>
+            <a:endParaRPr lang="en-US" sz="21156" dirty="0">
+              <a:solidFill>
+                <a:srgbClr val="717236"/>
+              </a:solidFill>
+              <a:latin typeface="Playfair Display"/>
+              <a:ea typeface="Playfair Display"/>
+              <a:cs typeface="Playfair Display"/>
+              <a:sym typeface="Playfair Display"/>
+              <a:hlinkClick r:id="rId2" tooltip="http://localhost:8080/db_testing/2526-3bhitm-sommerprojekt-l-graski/project/index.html"/>
+            </a:endParaRPr>
+          </a:p>
+        </p:txBody>
+      </p:sp>
+      <p:sp>
+        <p:nvSpPr>
+          <p:cNvPr id="9" name="Freeform 9"/>
           <p:cNvSpPr/>
           <p:nvPr/>
         </p:nvSpPr>
         <p:spPr>
-          <a:xfrm flipH="false" flipV="false" rot="0">
+          <a:xfrm>
             <a:off x="-652220" y="1441452"/>
             <a:ext cx="3361839" cy="2605425"/>
           </a:xfrm>
@@ -3351,9 +3403,9 @@
             <a:gdLst/>
             <a:ahLst/>
             <a:cxnLst/>
-            <a:rect r="r" b="b" t="t" l="l"/>
+            <a:rect l="l" t="t" r="r" b="b"/>
             <a:pathLst>
-              <a:path h="2605425" w="3361839">
+              <a:path w="3361839" h="2605425">
                 <a:moveTo>
                   <a:pt x="0" y="0"/>
                 </a:moveTo>
@@ -3365,6 +3417,59 @@
                 </a:lnTo>
                 <a:lnTo>
                   <a:pt x="0" y="2605425"/>
+                </a:lnTo>
+                <a:lnTo>
+                  <a:pt x="0" y="0"/>
+                </a:lnTo>
+                <a:close/>
+              </a:path>
+            </a:pathLst>
+          </a:custGeom>
+          <a:blipFill>
+            <a:blip r:embed="rId3"/>
+            <a:stretch>
+              <a:fillRect/>
+            </a:stretch>
+          </a:blipFill>
+        </p:spPr>
+        <p:txBody>
+          <a:bodyPr/>
+          <a:lstStyle/>
+          <a:p>
+            <a:endParaRPr lang="en-US"/>
+          </a:p>
+        </p:txBody>
+      </p:sp>
+      <p:sp>
+        <p:nvSpPr>
+          <p:cNvPr id="10" name="Freeform 10"/>
+          <p:cNvSpPr/>
+          <p:nvPr/>
+        </p:nvSpPr>
+        <p:spPr>
+          <a:xfrm>
+            <a:off x="15724718" y="6077049"/>
+            <a:ext cx="3069165" cy="2919543"/>
+          </a:xfrm>
+          <a:custGeom>
+            <a:avLst/>
+            <a:gdLst/>
+            <a:ahLst/>
+            <a:cxnLst/>
+            <a:rect l="l" t="t" r="r" b="b"/>
+            <a:pathLst>
+              <a:path w="3069165" h="2919543">
+                <a:moveTo>
+                  <a:pt x="0" y="0"/>
+                </a:moveTo>
+                <a:lnTo>
+                  <a:pt x="3069164" y="0"/>
+                </a:lnTo>
+                <a:lnTo>
+                  <a:pt x="3069164" y="2919543"/>
+                </a:lnTo>
+                <a:lnTo>
+                  <a:pt x="0" y="2919543"/>
                 </a:lnTo>
                 <a:lnTo>
                   <a:pt x="0" y="0"/>
@@ -3376,41 +3481,48 @@
           <a:blipFill>
             <a:blip r:embed="rId4"/>
             <a:stretch>
-              <a:fillRect l="0" t="0" r="0" b="0"/>
+              <a:fillRect/>
             </a:stretch>
           </a:blipFill>
         </p:spPr>
-      </p:sp>
-      <p:sp>
-        <p:nvSpPr>
-          <p:cNvPr name="Freeform 10" id="10"/>
+        <p:txBody>
+          <a:bodyPr/>
+          <a:lstStyle/>
+          <a:p>
+            <a:endParaRPr lang="en-US"/>
+          </a:p>
+        </p:txBody>
+      </p:sp>
+      <p:sp>
+        <p:nvSpPr>
+          <p:cNvPr id="11" name="Freeform 11"/>
           <p:cNvSpPr/>
           <p:nvPr/>
         </p:nvSpPr>
         <p:spPr>
-          <a:xfrm flipH="false" flipV="false" rot="0">
-            <a:off x="15724718" y="6077049"/>
-            <a:ext cx="3069165" cy="2919543"/>
+          <a:xfrm>
+            <a:off x="5157762" y="1225796"/>
+            <a:ext cx="1726413" cy="1318548"/>
           </a:xfrm>
           <a:custGeom>
             <a:avLst/>
             <a:gdLst/>
             <a:ahLst/>
             <a:cxnLst/>
-            <a:rect r="r" b="b" t="t" l="l"/>
+            <a:rect l="l" t="t" r="r" b="b"/>
             <a:pathLst>
-              <a:path h="2919543" w="3069165">
+              <a:path w="1726413" h="1318548">
                 <a:moveTo>
                   <a:pt x="0" y="0"/>
                 </a:moveTo>
                 <a:lnTo>
-                  <a:pt x="3069164" y="0"/>
-                </a:lnTo>
-                <a:lnTo>
-                  <a:pt x="3069164" y="2919543"/>
-                </a:lnTo>
-                <a:lnTo>
-                  <a:pt x="0" y="2919543"/>
+                  <a:pt x="1726413" y="0"/>
+                </a:lnTo>
+                <a:lnTo>
+                  <a:pt x="1726413" y="1318548"/>
+                </a:lnTo>
+                <a:lnTo>
+                  <a:pt x="0" y="1318548"/>
                 </a:lnTo>
                 <a:lnTo>
                   <a:pt x="0" y="0"/>
@@ -3420,22 +3532,35 @@
             </a:pathLst>
           </a:custGeom>
           <a:blipFill>
-            <a:blip r:embed="rId5"/>
+            <a:blip>
+              <a:extLst>
+                <a:ext uri="{96DAC541-7B7A-43D3-8B79-37D633B846F1}">
+                  <asvg:svgBlip xmlns:asvg="http://schemas.microsoft.com/office/drawing/2016/SVG/main" r:embed="rId5"/>
+                </a:ext>
+              </a:extLst>
+            </a:blip>
             <a:stretch>
-              <a:fillRect l="0" t="0" r="0" b="0"/>
+              <a:fillRect/>
             </a:stretch>
           </a:blipFill>
         </p:spPr>
-      </p:sp>
-      <p:sp>
-        <p:nvSpPr>
-          <p:cNvPr name="Freeform 11" id="11"/>
+        <p:txBody>
+          <a:bodyPr/>
+          <a:lstStyle/>
+          <a:p>
+            <a:endParaRPr lang="en-US"/>
+          </a:p>
+        </p:txBody>
+      </p:sp>
+      <p:sp>
+        <p:nvSpPr>
+          <p:cNvPr id="12" name="Freeform 12"/>
           <p:cNvSpPr/>
           <p:nvPr/>
         </p:nvSpPr>
         <p:spPr>
-          <a:xfrm flipH="false" flipV="false" rot="0">
-            <a:off x="5157762" y="1225796"/>
+          <a:xfrm>
+            <a:off x="12217381" y="7922808"/>
             <a:ext cx="1726413" cy="1318548"/>
           </a:xfrm>
           <a:custGeom>
@@ -3443,9 +3568,9 @@
             <a:gdLst/>
             <a:ahLst/>
             <a:cxnLst/>
-            <a:rect r="r" b="b" t="t" l="l"/>
+            <a:rect l="l" t="t" r="r" b="b"/>
             <a:pathLst>
-              <a:path h="1318548" w="1726413">
+              <a:path w="1726413" h="1318548">
                 <a:moveTo>
                   <a:pt x="0" y="0"/>
                 </a:moveTo>
@@ -3466,49 +3591,56 @@
             </a:pathLst>
           </a:custGeom>
           <a:blipFill>
-            <a:blip r:embed="rId6">
+            <a:blip>
               <a:extLst>
                 <a:ext uri="{96DAC541-7B7A-43D3-8B79-37D633B846F1}">
-                  <asvg:svgBlip xmlns:asvg="http://schemas.microsoft.com/office/drawing/2016/SVG/main" r:embed="rId7"/>
+                  <asvg:svgBlip xmlns:asvg="http://schemas.microsoft.com/office/drawing/2016/SVG/main" r:embed="rId5"/>
                 </a:ext>
               </a:extLst>
             </a:blip>
             <a:stretch>
-              <a:fillRect l="0" t="0" r="0" b="0"/>
+              <a:fillRect/>
             </a:stretch>
           </a:blipFill>
         </p:spPr>
-      </p:sp>
-      <p:sp>
-        <p:nvSpPr>
-          <p:cNvPr name="Freeform 12" id="12"/>
+        <p:txBody>
+          <a:bodyPr/>
+          <a:lstStyle/>
+          <a:p>
+            <a:endParaRPr lang="en-US"/>
+          </a:p>
+        </p:txBody>
+      </p:sp>
+      <p:sp>
+        <p:nvSpPr>
+          <p:cNvPr id="13" name="Freeform 13"/>
           <p:cNvSpPr/>
           <p:nvPr/>
         </p:nvSpPr>
         <p:spPr>
-          <a:xfrm flipH="false" flipV="false" rot="0">
-            <a:off x="12217381" y="7922808"/>
-            <a:ext cx="1726413" cy="1318548"/>
+          <a:xfrm rot="-1531308">
+            <a:off x="12889058" y="946356"/>
+            <a:ext cx="2109471" cy="1877429"/>
           </a:xfrm>
           <a:custGeom>
             <a:avLst/>
             <a:gdLst/>
             <a:ahLst/>
             <a:cxnLst/>
-            <a:rect r="r" b="b" t="t" l="l"/>
+            <a:rect l="l" t="t" r="r" b="b"/>
             <a:pathLst>
-              <a:path h="1318548" w="1726413">
+              <a:path w="2109471" h="1877429">
                 <a:moveTo>
                   <a:pt x="0" y="0"/>
                 </a:moveTo>
                 <a:lnTo>
-                  <a:pt x="1726413" y="0"/>
-                </a:lnTo>
-                <a:lnTo>
-                  <a:pt x="1726413" y="1318548"/>
-                </a:lnTo>
-                <a:lnTo>
-                  <a:pt x="0" y="1318548"/>
+                  <a:pt x="2109471" y="0"/>
+                </a:lnTo>
+                <a:lnTo>
+                  <a:pt x="2109471" y="1877428"/>
+                </a:lnTo>
+                <a:lnTo>
+                  <a:pt x="0" y="1877428"/>
                 </a:lnTo>
                 <a:lnTo>
                   <a:pt x="0" y="0"/>
@@ -3518,49 +3650,50 @@
             </a:pathLst>
           </a:custGeom>
           <a:blipFill>
-            <a:blip r:embed="rId6">
-              <a:extLst>
-                <a:ext uri="{96DAC541-7B7A-43D3-8B79-37D633B846F1}">
-                  <asvg:svgBlip xmlns:asvg="http://schemas.microsoft.com/office/drawing/2016/SVG/main" r:embed="rId7"/>
-                </a:ext>
-              </a:extLst>
-            </a:blip>
+            <a:blip r:embed="rId6"/>
             <a:stretch>
-              <a:fillRect l="0" t="0" r="0" b="0"/>
+              <a:fillRect/>
             </a:stretch>
           </a:blipFill>
         </p:spPr>
-      </p:sp>
-      <p:sp>
-        <p:nvSpPr>
-          <p:cNvPr name="Freeform 13" id="13"/>
+        <p:txBody>
+          <a:bodyPr/>
+          <a:lstStyle/>
+          <a:p>
+            <a:endParaRPr lang="en-US"/>
+          </a:p>
+        </p:txBody>
+      </p:sp>
+      <p:sp>
+        <p:nvSpPr>
+          <p:cNvPr id="14" name="Freeform 14"/>
           <p:cNvSpPr/>
           <p:nvPr/>
         </p:nvSpPr>
         <p:spPr>
-          <a:xfrm flipH="false" flipV="false" rot="-1531308">
-            <a:off x="12889058" y="946356"/>
-            <a:ext cx="2109471" cy="1877429"/>
+          <a:xfrm rot="-1554746">
+            <a:off x="2986808" y="6835635"/>
+            <a:ext cx="2003558" cy="2572787"/>
           </a:xfrm>
           <a:custGeom>
             <a:avLst/>
             <a:gdLst/>
             <a:ahLst/>
             <a:cxnLst/>
-            <a:rect r="r" b="b" t="t" l="l"/>
+            <a:rect l="l" t="t" r="r" b="b"/>
             <a:pathLst>
-              <a:path h="1877429" w="2109471">
+              <a:path w="2003558" h="2572787">
                 <a:moveTo>
                   <a:pt x="0" y="0"/>
                 </a:moveTo>
                 <a:lnTo>
-                  <a:pt x="2109471" y="0"/>
-                </a:lnTo>
-                <a:lnTo>
-                  <a:pt x="2109471" y="1877428"/>
-                </a:lnTo>
-                <a:lnTo>
-                  <a:pt x="0" y="1877428"/>
+                  <a:pt x="2003558" y="0"/>
+                </a:lnTo>
+                <a:lnTo>
+                  <a:pt x="2003558" y="2572787"/>
+                </a:lnTo>
+                <a:lnTo>
+                  <a:pt x="0" y="2572787"/>
                 </a:lnTo>
                 <a:lnTo>
                   <a:pt x="0" y="0"/>
@@ -3570,67 +3703,28 @@
             </a:pathLst>
           </a:custGeom>
           <a:blipFill>
-            <a:blip r:embed="rId8"/>
+            <a:blip r:embed="rId7"/>
             <a:stretch>
-              <a:fillRect l="0" t="0" r="0" b="0"/>
+              <a:fillRect/>
             </a:stretch>
           </a:blipFill>
         </p:spPr>
-      </p:sp>
-      <p:sp>
-        <p:nvSpPr>
-          <p:cNvPr name="Freeform 14" id="14"/>
-          <p:cNvSpPr/>
+        <p:txBody>
+          <a:bodyPr/>
+          <a:lstStyle/>
+          <a:p>
+            <a:endParaRPr lang="en-US"/>
+          </a:p>
+        </p:txBody>
+      </p:sp>
+      <p:sp>
+        <p:nvSpPr>
+          <p:cNvPr id="15" name="TextBox 15"/>
+          <p:cNvSpPr txBox="1"/>
           <p:nvPr/>
         </p:nvSpPr>
         <p:spPr>
-          <a:xfrm flipH="false" flipV="false" rot="-1554746">
-            <a:off x="2986808" y="6835635"/>
-            <a:ext cx="2003558" cy="2572787"/>
-          </a:xfrm>
-          <a:custGeom>
-            <a:avLst/>
-            <a:gdLst/>
-            <a:ahLst/>
-            <a:cxnLst/>
-            <a:rect r="r" b="b" t="t" l="l"/>
-            <a:pathLst>
-              <a:path h="2572787" w="2003558">
-                <a:moveTo>
-                  <a:pt x="0" y="0"/>
-                </a:moveTo>
-                <a:lnTo>
-                  <a:pt x="2003558" y="0"/>
-                </a:lnTo>
-                <a:lnTo>
-                  <a:pt x="2003558" y="2572787"/>
-                </a:lnTo>
-                <a:lnTo>
-                  <a:pt x="0" y="2572787"/>
-                </a:lnTo>
-                <a:lnTo>
-                  <a:pt x="0" y="0"/>
-                </a:lnTo>
-                <a:close/>
-              </a:path>
-            </a:pathLst>
-          </a:custGeom>
-          <a:blipFill>
-            <a:blip r:embed="rId9"/>
-            <a:stretch>
-              <a:fillRect l="0" t="0" r="0" b="0"/>
-            </a:stretch>
-          </a:blipFill>
-        </p:spPr>
-      </p:sp>
-      <p:sp>
-        <p:nvSpPr>
-          <p:cNvPr name="TextBox 15" id="15"/>
-          <p:cNvSpPr txBox="true"/>
-          <p:nvPr/>
-        </p:nvSpPr>
-        <p:spPr>
-          <a:xfrm rot="0">
+          <a:xfrm>
             <a:off x="6320129" y="6317624"/>
             <a:ext cx="5647742" cy="1775357"/>
           </a:xfrm>
@@ -3639,7 +3733,7 @@
           </a:prstGeom>
         </p:spPr>
         <p:txBody>
-          <a:bodyPr anchor="t" rtlCol="false" tIns="0" lIns="0" bIns="0" rIns="0">
+          <a:bodyPr lIns="0" tIns="0" rIns="0" bIns="0" rtlCol="0" anchor="t">
             <a:spAutoFit/>
           </a:bodyPr>
           <a:lstStyle/>
@@ -3662,19 +3756,7 @@
                 <a:cs typeface="Agrandir"/>
                 <a:sym typeface="Agrandir"/>
               </a:rPr>
-              <a:t>Schmuck, d</a:t>
-            </a:r>
-            <a:r>
-              <a:rPr lang="en-US" sz="3695">
-                <a:solidFill>
-                  <a:srgbClr val="5A5A2C"/>
-                </a:solidFill>
-                <a:latin typeface="Agrandir"/>
-                <a:ea typeface="Agrandir"/>
-                <a:cs typeface="Agrandir"/>
-                <a:sym typeface="Agrandir"/>
-              </a:rPr>
-              <a:t>er</a:t>
+              <a:t>Schmuck, der</a:t>
             </a:r>
           </a:p>
           <a:p>
@@ -3732,13 +3814,14 @@
 </file>
 
 <file path=ppt/slides/slide2.xml><?xml version="1.0" encoding="utf-8"?>
-<p:sld xmlns:p="http://schemas.openxmlformats.org/presentationml/2006/main" xmlns:a="http://schemas.openxmlformats.org/drawingml/2006/main" xmlns:r="http://schemas.openxmlformats.org/officeDocument/2006/relationships">
+<p:sld xmlns:a="http://schemas.openxmlformats.org/drawingml/2006/main" xmlns:r="http://schemas.openxmlformats.org/officeDocument/2006/relationships" xmlns:p="http://schemas.openxmlformats.org/presentationml/2006/main">
   <p:cSld>
     <p:bg>
       <p:bgPr>
         <a:solidFill>
           <a:srgbClr val="F6F3E4"/>
         </a:solidFill>
+        <a:effectLst/>
       </p:bgPr>
     </p:bg>
     <p:spTree>
@@ -3757,12 +3840,12 @@
       </p:grpSpPr>
       <p:grpSp>
         <p:nvGrpSpPr>
-          <p:cNvPr name="Group 2" id="2"/>
+          <p:cNvPr id="2" name="Group 2"/>
           <p:cNvGrpSpPr/>
           <p:nvPr/>
         </p:nvGrpSpPr>
         <p:grpSpPr>
-          <a:xfrm rot="0">
+          <a:xfrm>
             <a:off x="11377022" y="0"/>
             <a:ext cx="6910978" cy="10287000"/>
             <a:chOff x="0" y="0"/>
@@ -3771,12 +3854,12 @@
         </p:grpSpPr>
         <p:sp>
           <p:nvSpPr>
-            <p:cNvPr name="Freeform 3" id="3"/>
+            <p:cNvPr id="3" name="Freeform 3"/>
             <p:cNvSpPr/>
             <p:nvPr/>
           </p:nvSpPr>
           <p:spPr>
-            <a:xfrm flipH="false" flipV="false" rot="0">
+            <a:xfrm>
               <a:off x="0" y="0"/>
               <a:ext cx="1820175" cy="2709333"/>
             </a:xfrm>
@@ -3785,9 +3868,9 @@
               <a:gdLst/>
               <a:ahLst/>
               <a:cxnLst/>
-              <a:rect r="r" b="b" t="t" l="l"/>
+              <a:rect l="l" t="t" r="r" b="b"/>
               <a:pathLst>
-                <a:path h="2709333" w="1820175">
+                <a:path w="1820175" h="2709333">
                   <a:moveTo>
                     <a:pt x="0" y="0"/>
                   </a:moveTo>
@@ -3808,11 +3891,18 @@
               <a:srgbClr val="5A5A2C"/>
             </a:solidFill>
           </p:spPr>
+          <p:txBody>
+            <a:bodyPr/>
+            <a:lstStyle/>
+            <a:p>
+              <a:endParaRPr lang="en-US"/>
+            </a:p>
+          </p:txBody>
         </p:sp>
         <p:sp>
           <p:nvSpPr>
-            <p:cNvPr name="TextBox 4" id="4"/>
-            <p:cNvSpPr txBox="true"/>
+            <p:cNvPr id="4" name="TextBox 4"/>
+            <p:cNvSpPr txBox="1"/>
             <p:nvPr/>
           </p:nvSpPr>
           <p:spPr>
@@ -3825,7 +3915,7 @@
             </a:prstGeom>
           </p:spPr>
           <p:txBody>
-            <a:bodyPr anchor="ctr" rtlCol="false" tIns="50800" lIns="50800" bIns="50800" rIns="50800"/>
+            <a:bodyPr lIns="50800" tIns="50800" rIns="50800" bIns="50800" rtlCol="0" anchor="ctr"/>
             <a:lstStyle/>
             <a:p>
               <a:pPr algn="ctr">
@@ -3836,18 +3926,19 @@
                   <a:spcPct val="0"/>
                 </a:spcBef>
               </a:pPr>
+              <a:endParaRPr/>
             </a:p>
           </p:txBody>
         </p:sp>
       </p:grpSp>
       <p:sp>
         <p:nvSpPr>
-          <p:cNvPr name="TextBox 5" id="5"/>
-          <p:cNvSpPr txBox="true"/>
+          <p:cNvPr id="5" name="TextBox 5"/>
+          <p:cNvSpPr txBox="1"/>
           <p:nvPr/>
         </p:nvSpPr>
         <p:spPr>
-          <a:xfrm rot="0">
+          <a:xfrm>
             <a:off x="2113262" y="1589764"/>
             <a:ext cx="6684591" cy="3000884"/>
           </a:xfrm>
@@ -3856,7 +3947,7 @@
           </a:prstGeom>
         </p:spPr>
         <p:txBody>
-          <a:bodyPr anchor="t" rtlCol="false" tIns="0" lIns="0" bIns="0" rIns="0">
+          <a:bodyPr lIns="0" tIns="0" rIns="0" bIns="0" rtlCol="0" anchor="t">
             <a:spAutoFit/>
           </a:bodyPr>
           <a:lstStyle/>
@@ -3867,7 +3958,7 @@
               </a:lnSpc>
             </a:pPr>
             <a:r>
-              <a:rPr lang="en-US" sz="8727">
+              <a:rPr lang="en-US" sz="8727" dirty="0">
                 <a:solidFill>
                   <a:srgbClr val="717236"/>
                 </a:solidFill>
@@ -3876,17 +3967,10 @@
                 <a:cs typeface="Playfair Display"/>
                 <a:sym typeface="Playfair Display"/>
               </a:rPr>
-              <a:t>Was ist</a:t>
-            </a:r>
-          </a:p>
-          <a:p>
-            <a:pPr algn="l">
-              <a:lnSpc>
-                <a:spcPts val="12044"/>
-              </a:lnSpc>
-            </a:pPr>
-            <a:r>
-              <a:rPr lang="en-US" sz="8727">
+              <a:t>Was </a:t>
+            </a:r>
+            <a:r>
+              <a:rPr lang="en-US" sz="8727" dirty="0" err="1">
                 <a:solidFill>
                   <a:srgbClr val="717236"/>
                 </a:solidFill>
@@ -3894,21 +3978,58 @@
                 <a:ea typeface="Playfair Display"/>
                 <a:cs typeface="Playfair Display"/>
                 <a:sym typeface="Playfair Display"/>
-                <a:hlinkClick r:id="rId2" tooltip="http://localhost:8080/db_testing/2526-3bhitm-sommerprojekt-l-graski/project/index.html"/>
+              </a:rPr>
+              <a:t>ist</a:t>
+            </a:r>
+            <a:endParaRPr lang="en-US" sz="8727" dirty="0">
+              <a:solidFill>
+                <a:srgbClr val="717236"/>
+              </a:solidFill>
+              <a:latin typeface="Playfair Display"/>
+              <a:ea typeface="Playfair Display"/>
+              <a:cs typeface="Playfair Display"/>
+              <a:sym typeface="Playfair Display"/>
+            </a:endParaRPr>
+          </a:p>
+          <a:p>
+            <a:pPr algn="l">
+              <a:lnSpc>
+                <a:spcPts val="12044"/>
+              </a:lnSpc>
+            </a:pPr>
+            <a:r>
+              <a:rPr lang="en-US" sz="8727" dirty="0" err="1">
+                <a:solidFill>
+                  <a:srgbClr val="717236"/>
+                </a:solidFill>
+                <a:latin typeface="Playfair Display"/>
+                <a:ea typeface="Playfair Display"/>
+                <a:cs typeface="Playfair Display"/>
+                <a:sym typeface="Playfair Display"/>
               </a:rPr>
               <a:t>Oréon</a:t>
             </a:r>
-          </a:p>
-        </p:txBody>
-      </p:sp>
-      <p:sp>
-        <p:nvSpPr>
-          <p:cNvPr name="TextBox 6" id="6"/>
-          <p:cNvSpPr txBox="true"/>
+            <a:endParaRPr lang="en-US" sz="8727" dirty="0">
+              <a:solidFill>
+                <a:srgbClr val="717236"/>
+              </a:solidFill>
+              <a:latin typeface="Playfair Display"/>
+              <a:ea typeface="Playfair Display"/>
+              <a:cs typeface="Playfair Display"/>
+              <a:sym typeface="Playfair Display"/>
+              <a:hlinkClick r:id="rId2" tooltip="http://localhost:8080/db_testing/2526-3bhitm-sommerprojekt-l-graski/project/index.html"/>
+            </a:endParaRPr>
+          </a:p>
+        </p:txBody>
+      </p:sp>
+      <p:sp>
+        <p:nvSpPr>
+          <p:cNvPr id="6" name="TextBox 6"/>
+          <p:cNvSpPr txBox="1"/>
           <p:nvPr/>
         </p:nvSpPr>
         <p:spPr>
-          <a:xfrm rot="0">
+          <a:xfrm>
             <a:off x="2113262" y="5087887"/>
             <a:ext cx="6987385" cy="1513849"/>
           </a:xfrm>
@@ -3917,7 +4038,7 @@
           </a:prstGeom>
         </p:spPr>
         <p:txBody>
-          <a:bodyPr anchor="t" rtlCol="false" tIns="0" lIns="0" bIns="0" rIns="0">
+          <a:bodyPr lIns="0" tIns="0" rIns="0" bIns="0" rtlCol="0" anchor="t">
             <a:spAutoFit/>
           </a:bodyPr>
           <a:lstStyle/>
@@ -3944,12 +4065,12 @@
       </p:sp>
       <p:sp>
         <p:nvSpPr>
-          <p:cNvPr name="Freeform 7" id="7"/>
+          <p:cNvPr id="7" name="Freeform 7"/>
           <p:cNvSpPr/>
           <p:nvPr/>
         </p:nvSpPr>
         <p:spPr>
-          <a:xfrm flipH="false" flipV="false" rot="1702376">
+          <a:xfrm rot="1702376">
             <a:off x="9175023" y="4792498"/>
             <a:ext cx="7132475" cy="3637562"/>
           </a:xfrm>
@@ -3958,9 +4079,9 @@
             <a:gdLst/>
             <a:ahLst/>
             <a:cxnLst/>
-            <a:rect r="r" b="b" t="t" l="l"/>
+            <a:rect l="l" t="t" r="r" b="b"/>
             <a:pathLst>
-              <a:path h="3637562" w="7132475">
+              <a:path w="7132475" h="3637562">
                 <a:moveTo>
                   <a:pt x="0" y="0"/>
                 </a:moveTo>
@@ -3983,19 +4104,26 @@
           <a:blipFill>
             <a:blip r:embed="rId3"/>
             <a:stretch>
-              <a:fillRect l="0" t="0" r="0" b="0"/>
+              <a:fillRect/>
             </a:stretch>
           </a:blipFill>
         </p:spPr>
-      </p:sp>
-      <p:sp>
-        <p:nvSpPr>
-          <p:cNvPr name="Freeform 8" id="8"/>
+        <p:txBody>
+          <a:bodyPr/>
+          <a:lstStyle/>
+          <a:p>
+            <a:endParaRPr lang="en-US"/>
+          </a:p>
+        </p:txBody>
+      </p:sp>
+      <p:sp>
+        <p:nvSpPr>
+          <p:cNvPr id="8" name="Freeform 8"/>
           <p:cNvSpPr/>
           <p:nvPr/>
         </p:nvSpPr>
         <p:spPr>
-          <a:xfrm flipH="false" flipV="false" rot="-2819360">
+          <a:xfrm rot="-2819360">
             <a:off x="15164053" y="1579925"/>
             <a:ext cx="3857979" cy="4592832"/>
           </a:xfrm>
@@ -4004,9 +4132,9 @@
             <a:gdLst/>
             <a:ahLst/>
             <a:cxnLst/>
-            <a:rect r="r" b="b" t="t" l="l"/>
+            <a:rect l="l" t="t" r="r" b="b"/>
             <a:pathLst>
-              <a:path h="4592832" w="3857979">
+              <a:path w="3857979" h="4592832">
                 <a:moveTo>
                   <a:pt x="0" y="0"/>
                 </a:moveTo>
@@ -4029,19 +4157,26 @@
           <a:blipFill>
             <a:blip r:embed="rId4"/>
             <a:stretch>
-              <a:fillRect l="0" t="0" r="0" b="0"/>
+              <a:fillRect/>
             </a:stretch>
           </a:blipFill>
         </p:spPr>
-      </p:sp>
-      <p:sp>
-        <p:nvSpPr>
-          <p:cNvPr name="Freeform 9" id="9"/>
+        <p:txBody>
+          <a:bodyPr/>
+          <a:lstStyle/>
+          <a:p>
+            <a:endParaRPr lang="en-US"/>
+          </a:p>
+        </p:txBody>
+      </p:sp>
+      <p:sp>
+        <p:nvSpPr>
+          <p:cNvPr id="9" name="Freeform 9"/>
           <p:cNvSpPr/>
           <p:nvPr/>
         </p:nvSpPr>
         <p:spPr>
-          <a:xfrm flipH="false" flipV="false" rot="0">
+          <a:xfrm>
             <a:off x="740261" y="8733985"/>
             <a:ext cx="1373001" cy="1048629"/>
           </a:xfrm>
@@ -4050,9 +4185,9 @@
             <a:gdLst/>
             <a:ahLst/>
             <a:cxnLst/>
-            <a:rect r="r" b="b" t="t" l="l"/>
+            <a:rect l="l" t="t" r="r" b="b"/>
             <a:pathLst>
-              <a:path h="1048629" w="1373001">
+              <a:path w="1373001" h="1048629">
                 <a:moveTo>
                   <a:pt x="0" y="0"/>
                 </a:moveTo>
@@ -4073,27 +4208,34 @@
             </a:pathLst>
           </a:custGeom>
           <a:blipFill>
-            <a:blip r:embed="rId5">
+            <a:blip>
               <a:extLst>
                 <a:ext uri="{96DAC541-7B7A-43D3-8B79-37D633B846F1}">
-                  <asvg:svgBlip xmlns:asvg="http://schemas.microsoft.com/office/drawing/2016/SVG/main" r:embed="rId6"/>
+                  <asvg:svgBlip xmlns:asvg="http://schemas.microsoft.com/office/drawing/2016/SVG/main" r:embed="rId5"/>
                 </a:ext>
               </a:extLst>
             </a:blip>
             <a:stretch>
-              <a:fillRect l="0" t="0" r="0" b="0"/>
+              <a:fillRect/>
             </a:stretch>
           </a:blipFill>
         </p:spPr>
-      </p:sp>
-      <p:sp>
-        <p:nvSpPr>
-          <p:cNvPr name="Freeform 10" id="10"/>
+        <p:txBody>
+          <a:bodyPr/>
+          <a:lstStyle/>
+          <a:p>
+            <a:endParaRPr lang="en-US"/>
+          </a:p>
+        </p:txBody>
+      </p:sp>
+      <p:sp>
+        <p:nvSpPr>
+          <p:cNvPr id="10" name="Freeform 10"/>
           <p:cNvSpPr/>
           <p:nvPr/>
         </p:nvSpPr>
         <p:spPr>
-          <a:xfrm flipH="false" flipV="false" rot="0">
+          <a:xfrm>
             <a:off x="8409968" y="820484"/>
             <a:ext cx="1726413" cy="1318548"/>
           </a:xfrm>
@@ -4102,9 +4244,9 @@
             <a:gdLst/>
             <a:ahLst/>
             <a:cxnLst/>
-            <a:rect r="r" b="b" t="t" l="l"/>
+            <a:rect l="l" t="t" r="r" b="b"/>
             <a:pathLst>
-              <a:path h="1318548" w="1726413">
+              <a:path w="1726413" h="1318548">
                 <a:moveTo>
                   <a:pt x="0" y="0"/>
                 </a:moveTo>
@@ -4125,18 +4267,25 @@
             </a:pathLst>
           </a:custGeom>
           <a:blipFill>
-            <a:blip r:embed="rId5">
+            <a:blip>
               <a:extLst>
                 <a:ext uri="{96DAC541-7B7A-43D3-8B79-37D633B846F1}">
-                  <asvg:svgBlip xmlns:asvg="http://schemas.microsoft.com/office/drawing/2016/SVG/main" r:embed="rId6"/>
+                  <asvg:svgBlip xmlns:asvg="http://schemas.microsoft.com/office/drawing/2016/SVG/main" r:embed="rId5"/>
                 </a:ext>
               </a:extLst>
             </a:blip>
             <a:stretch>
-              <a:fillRect l="0" t="0" r="0" b="0"/>
+              <a:fillRect/>
             </a:stretch>
           </a:blipFill>
         </p:spPr>
+        <p:txBody>
+          <a:bodyPr/>
+          <a:lstStyle/>
+          <a:p>
+            <a:endParaRPr lang="en-US"/>
+          </a:p>
+        </p:txBody>
       </p:sp>
     </p:spTree>
   </p:cSld>
@@ -4147,13 +4296,14 @@
 </file>
 
 <file path=ppt/slides/slide3.xml><?xml version="1.0" encoding="utf-8"?>
-<p:sld xmlns:p="http://schemas.openxmlformats.org/presentationml/2006/main" xmlns:a="http://schemas.openxmlformats.org/drawingml/2006/main" xmlns:r="http://schemas.openxmlformats.org/officeDocument/2006/relationships">
+<p:sld xmlns:a="http://schemas.openxmlformats.org/drawingml/2006/main" xmlns:r="http://schemas.openxmlformats.org/officeDocument/2006/relationships" xmlns:p="http://schemas.openxmlformats.org/presentationml/2006/main">
   <p:cSld>
     <p:bg>
       <p:bgPr>
         <a:solidFill>
           <a:srgbClr val="F6F3E4"/>
         </a:solidFill>
+        <a:effectLst/>
       </p:bgPr>
     </p:bg>
     <p:spTree>
@@ -4172,12 +4322,12 @@
       </p:grpSpPr>
       <p:sp>
         <p:nvSpPr>
-          <p:cNvPr name="TextBox 2" id="2"/>
-          <p:cNvSpPr txBox="true"/>
+          <p:cNvPr id="2" name="TextBox 2"/>
+          <p:cNvSpPr txBox="1"/>
           <p:nvPr/>
         </p:nvSpPr>
         <p:spPr>
-          <a:xfrm rot="0">
+          <a:xfrm>
             <a:off x="5650308" y="1599289"/>
             <a:ext cx="6684591" cy="1376296"/>
           </a:xfrm>
@@ -4186,7 +4336,7 @@
           </a:prstGeom>
         </p:spPr>
         <p:txBody>
-          <a:bodyPr anchor="t" rtlCol="false" tIns="0" lIns="0" bIns="0" rIns="0">
+          <a:bodyPr lIns="0" tIns="0" rIns="0" bIns="0" rtlCol="0" anchor="t">
             <a:spAutoFit/>
           </a:bodyPr>
           <a:lstStyle/>
@@ -4213,12 +4363,12 @@
       </p:sp>
       <p:sp>
         <p:nvSpPr>
-          <p:cNvPr name="TextBox 3" id="3"/>
-          <p:cNvSpPr txBox="true"/>
+          <p:cNvPr id="3" name="TextBox 3"/>
+          <p:cNvSpPr txBox="1"/>
           <p:nvPr/>
         </p:nvSpPr>
         <p:spPr>
-          <a:xfrm rot="0">
+          <a:xfrm>
             <a:off x="5650308" y="4171424"/>
             <a:ext cx="6987385" cy="1999624"/>
           </a:xfrm>
@@ -4227,12 +4377,12 @@
           </a:prstGeom>
         </p:spPr>
         <p:txBody>
-          <a:bodyPr anchor="t" rtlCol="false" tIns="0" lIns="0" bIns="0" rIns="0">
+          <a:bodyPr lIns="0" tIns="0" rIns="0" bIns="0" rtlCol="0" anchor="t">
             <a:spAutoFit/>
           </a:bodyPr>
           <a:lstStyle/>
           <a:p>
-            <a:pPr algn="l" marL="613872" indent="-306936" lvl="1">
+            <a:pPr marL="613872" lvl="1" indent="-306936" algn="l">
               <a:lnSpc>
                 <a:spcPts val="3866"/>
               </a:lnSpc>
@@ -4253,7 +4403,7 @@
             </a:r>
           </a:p>
           <a:p>
-            <a:pPr algn="l" marL="613872" indent="-306936" lvl="1">
+            <a:pPr marL="613872" lvl="1" indent="-306936" algn="l">
               <a:lnSpc>
                 <a:spcPts val="3866"/>
               </a:lnSpc>
@@ -4274,7 +4424,7 @@
             </a:r>
           </a:p>
           <a:p>
-            <a:pPr algn="l" marL="613872" indent="-306936" lvl="1">
+            <a:pPr marL="613872" lvl="1" indent="-306936" algn="l">
               <a:lnSpc>
                 <a:spcPts val="3866"/>
               </a:lnSpc>
@@ -4298,12 +4448,12 @@
       </p:sp>
       <p:sp>
         <p:nvSpPr>
-          <p:cNvPr name="Freeform 4" id="4"/>
+          <p:cNvPr id="4" name="Freeform 4"/>
           <p:cNvSpPr/>
           <p:nvPr/>
         </p:nvSpPr>
         <p:spPr>
-          <a:xfrm flipH="false" flipV="false" rot="0">
+          <a:xfrm>
             <a:off x="-589358" y="2033714"/>
             <a:ext cx="3833208" cy="2252010"/>
           </a:xfrm>
@@ -4312,9 +4462,9 @@
             <a:gdLst/>
             <a:ahLst/>
             <a:cxnLst/>
-            <a:rect r="r" b="b" t="t" l="l"/>
+            <a:rect l="l" t="t" r="r" b="b"/>
             <a:pathLst>
-              <a:path h="2252010" w="3833208">
+              <a:path w="3833208" h="2252010">
                 <a:moveTo>
                   <a:pt x="0" y="0"/>
                 </a:moveTo>
@@ -4337,19 +4487,26 @@
           <a:blipFill>
             <a:blip r:embed="rId2"/>
             <a:stretch>
-              <a:fillRect l="0" t="0" r="0" b="0"/>
+              <a:fillRect/>
             </a:stretch>
           </a:blipFill>
         </p:spPr>
-      </p:sp>
-      <p:sp>
-        <p:nvSpPr>
-          <p:cNvPr name="Freeform 5" id="5"/>
+        <p:txBody>
+          <a:bodyPr/>
+          <a:lstStyle/>
+          <a:p>
+            <a:endParaRPr lang="en-US"/>
+          </a:p>
+        </p:txBody>
+      </p:sp>
+      <p:sp>
+        <p:nvSpPr>
+          <p:cNvPr id="5" name="Freeform 5"/>
           <p:cNvSpPr/>
           <p:nvPr/>
         </p:nvSpPr>
         <p:spPr>
-          <a:xfrm flipH="false" flipV="false" rot="-1238078">
+          <a:xfrm rot="-1238078">
             <a:off x="2070997" y="7495399"/>
             <a:ext cx="3120414" cy="4006952"/>
           </a:xfrm>
@@ -4358,9 +4515,9 @@
             <a:gdLst/>
             <a:ahLst/>
             <a:cxnLst/>
-            <a:rect r="r" b="b" t="t" l="l"/>
+            <a:rect l="l" t="t" r="r" b="b"/>
             <a:pathLst>
-              <a:path h="4006952" w="3120414">
+              <a:path w="3120414" h="4006952">
                 <a:moveTo>
                   <a:pt x="0" y="0"/>
                 </a:moveTo>
@@ -4383,19 +4540,26 @@
           <a:blipFill>
             <a:blip r:embed="rId3"/>
             <a:stretch>
-              <a:fillRect l="0" t="0" r="0" b="0"/>
+              <a:fillRect/>
             </a:stretch>
           </a:blipFill>
         </p:spPr>
-      </p:sp>
-      <p:sp>
-        <p:nvSpPr>
-          <p:cNvPr name="Freeform 6" id="6"/>
+        <p:txBody>
+          <a:bodyPr/>
+          <a:lstStyle/>
+          <a:p>
+            <a:endParaRPr lang="en-US"/>
+          </a:p>
+        </p:txBody>
+      </p:sp>
+      <p:sp>
+        <p:nvSpPr>
+          <p:cNvPr id="6" name="Freeform 6"/>
           <p:cNvSpPr/>
           <p:nvPr/>
         </p:nvSpPr>
         <p:spPr>
-          <a:xfrm flipH="false" flipV="false" rot="0">
+          <a:xfrm>
             <a:off x="14869460" y="6851621"/>
             <a:ext cx="4295747" cy="2647254"/>
           </a:xfrm>
@@ -4404,9 +4568,9 @@
             <a:gdLst/>
             <a:ahLst/>
             <a:cxnLst/>
-            <a:rect r="r" b="b" t="t" l="l"/>
+            <a:rect l="l" t="t" r="r" b="b"/>
             <a:pathLst>
-              <a:path h="2647254" w="4295747">
+              <a:path w="4295747" h="2647254">
                 <a:moveTo>
                   <a:pt x="0" y="0"/>
                 </a:moveTo>
@@ -4429,19 +4593,26 @@
           <a:blipFill>
             <a:blip r:embed="rId4"/>
             <a:stretch>
-              <a:fillRect l="0" t="0" r="0" b="0"/>
+              <a:fillRect/>
             </a:stretch>
           </a:blipFill>
         </p:spPr>
-      </p:sp>
-      <p:sp>
-        <p:nvSpPr>
-          <p:cNvPr name="Freeform 7" id="7"/>
+        <p:txBody>
+          <a:bodyPr/>
+          <a:lstStyle/>
+          <a:p>
+            <a:endParaRPr lang="en-US"/>
+          </a:p>
+        </p:txBody>
+      </p:sp>
+      <p:sp>
+        <p:nvSpPr>
+          <p:cNvPr id="7" name="Freeform 7"/>
           <p:cNvSpPr/>
           <p:nvPr/>
         </p:nvSpPr>
         <p:spPr>
-          <a:xfrm flipH="false" flipV="false" rot="-8638927">
+          <a:xfrm rot="-8638927">
             <a:off x="13473005" y="-969429"/>
             <a:ext cx="2887297" cy="3996258"/>
           </a:xfrm>
@@ -4450,9 +4621,9 @@
             <a:gdLst/>
             <a:ahLst/>
             <a:cxnLst/>
-            <a:rect r="r" b="b" t="t" l="l"/>
+            <a:rect l="l" t="t" r="r" b="b"/>
             <a:pathLst>
-              <a:path h="3996258" w="2887297">
+              <a:path w="2887297" h="3996258">
                 <a:moveTo>
                   <a:pt x="0" y="0"/>
                 </a:moveTo>
@@ -4475,19 +4646,26 @@
           <a:blipFill>
             <a:blip r:embed="rId5"/>
             <a:stretch>
-              <a:fillRect l="0" t="0" r="0" b="0"/>
+              <a:fillRect/>
             </a:stretch>
           </a:blipFill>
         </p:spPr>
-      </p:sp>
-      <p:sp>
-        <p:nvSpPr>
-          <p:cNvPr name="Freeform 8" id="8"/>
+        <p:txBody>
+          <a:bodyPr/>
+          <a:lstStyle/>
+          <a:p>
+            <a:endParaRPr lang="en-US"/>
+          </a:p>
+        </p:txBody>
+      </p:sp>
+      <p:sp>
+        <p:nvSpPr>
+          <p:cNvPr id="8" name="Freeform 8"/>
           <p:cNvSpPr/>
           <p:nvPr/>
         </p:nvSpPr>
         <p:spPr>
-          <a:xfrm flipH="true" flipV="false" rot="0">
+          <a:xfrm flipH="1">
             <a:off x="13854371" y="5755552"/>
             <a:ext cx="1726413" cy="1318548"/>
           </a:xfrm>
@@ -4496,9 +4674,9 @@
             <a:gdLst/>
             <a:ahLst/>
             <a:cxnLst/>
-            <a:rect r="r" b="b" t="t" l="l"/>
+            <a:rect l="l" t="t" r="r" b="b"/>
             <a:pathLst>
-              <a:path h="1318548" w="1726413">
+              <a:path w="1726413" h="1318548">
                 <a:moveTo>
                   <a:pt x="1726413" y="0"/>
                 </a:moveTo>
@@ -4519,27 +4697,34 @@
             </a:pathLst>
           </a:custGeom>
           <a:blipFill>
-            <a:blip r:embed="rId6">
+            <a:blip>
               <a:extLst>
                 <a:ext uri="{96DAC541-7B7A-43D3-8B79-37D633B846F1}">
-                  <asvg:svgBlip xmlns:asvg="http://schemas.microsoft.com/office/drawing/2016/SVG/main" r:embed="rId7"/>
+                  <asvg:svgBlip xmlns:asvg="http://schemas.microsoft.com/office/drawing/2016/SVG/main" r:embed="rId6"/>
                 </a:ext>
               </a:extLst>
             </a:blip>
             <a:stretch>
-              <a:fillRect l="0" t="0" r="0" b="0"/>
+              <a:fillRect/>
             </a:stretch>
           </a:blipFill>
         </p:spPr>
-      </p:sp>
-      <p:sp>
-        <p:nvSpPr>
-          <p:cNvPr name="Freeform 9" id="9"/>
+        <p:txBody>
+          <a:bodyPr/>
+          <a:lstStyle/>
+          <a:p>
+            <a:endParaRPr lang="en-US"/>
+          </a:p>
+        </p:txBody>
+      </p:sp>
+      <p:sp>
+        <p:nvSpPr>
+          <p:cNvPr id="9" name="Freeform 9"/>
           <p:cNvSpPr/>
           <p:nvPr/>
         </p:nvSpPr>
         <p:spPr>
-          <a:xfrm flipH="false" flipV="false" rot="0">
+          <a:xfrm>
             <a:off x="3418501" y="1900608"/>
             <a:ext cx="1648591" cy="1259111"/>
           </a:xfrm>
@@ -4548,9 +4733,9 @@
             <a:gdLst/>
             <a:ahLst/>
             <a:cxnLst/>
-            <a:rect r="r" b="b" t="t" l="l"/>
+            <a:rect l="l" t="t" r="r" b="b"/>
             <a:pathLst>
-              <a:path h="1259111" w="1648591">
+              <a:path w="1648591" h="1259111">
                 <a:moveTo>
                   <a:pt x="0" y="0"/>
                 </a:moveTo>
@@ -4571,18 +4756,25 @@
             </a:pathLst>
           </a:custGeom>
           <a:blipFill>
-            <a:blip r:embed="rId6">
+            <a:blip>
               <a:extLst>
                 <a:ext uri="{96DAC541-7B7A-43D3-8B79-37D633B846F1}">
-                  <asvg:svgBlip xmlns:asvg="http://schemas.microsoft.com/office/drawing/2016/SVG/main" r:embed="rId7"/>
+                  <asvg:svgBlip xmlns:asvg="http://schemas.microsoft.com/office/drawing/2016/SVG/main" r:embed="rId6"/>
                 </a:ext>
               </a:extLst>
             </a:blip>
             <a:stretch>
-              <a:fillRect l="0" t="0" r="0" b="0"/>
+              <a:fillRect/>
             </a:stretch>
           </a:blipFill>
         </p:spPr>
+        <p:txBody>
+          <a:bodyPr/>
+          <a:lstStyle/>
+          <a:p>
+            <a:endParaRPr lang="en-US"/>
+          </a:p>
+        </p:txBody>
       </p:sp>
     </p:spTree>
   </p:cSld>
@@ -4593,13 +4785,14 @@
 </file>
 
 <file path=ppt/slides/slide4.xml><?xml version="1.0" encoding="utf-8"?>
-<p:sld xmlns:p="http://schemas.openxmlformats.org/presentationml/2006/main" xmlns:a="http://schemas.openxmlformats.org/drawingml/2006/main" xmlns:r="http://schemas.openxmlformats.org/officeDocument/2006/relationships">
+<p:sld xmlns:a="http://schemas.openxmlformats.org/drawingml/2006/main" xmlns:r="http://schemas.openxmlformats.org/officeDocument/2006/relationships" xmlns:p="http://schemas.openxmlformats.org/presentationml/2006/main">
   <p:cSld>
     <p:bg>
       <p:bgPr>
         <a:solidFill>
           <a:srgbClr val="F6F3E4"/>
         </a:solidFill>
+        <a:effectLst/>
       </p:bgPr>
     </p:bg>
     <p:spTree>
@@ -4618,12 +4811,12 @@
       </p:grpSpPr>
       <p:grpSp>
         <p:nvGrpSpPr>
-          <p:cNvPr name="Group 2" id="2"/>
+          <p:cNvPr id="2" name="Group 2"/>
           <p:cNvGrpSpPr/>
           <p:nvPr/>
         </p:nvGrpSpPr>
         <p:grpSpPr>
-          <a:xfrm rot="0">
+          <a:xfrm>
             <a:off x="6451837" y="0"/>
             <a:ext cx="11836163" cy="10287000"/>
             <a:chOff x="0" y="0"/>
@@ -4632,12 +4825,12 @@
         </p:grpSpPr>
         <p:sp>
           <p:nvSpPr>
-            <p:cNvPr name="Freeform 3" id="3"/>
+            <p:cNvPr id="3" name="Freeform 3"/>
             <p:cNvSpPr/>
             <p:nvPr/>
           </p:nvSpPr>
           <p:spPr>
-            <a:xfrm flipH="false" flipV="false" rot="0">
+            <a:xfrm>
               <a:off x="0" y="0"/>
               <a:ext cx="3117343" cy="2709333"/>
             </a:xfrm>
@@ -4646,9 +4839,9 @@
               <a:gdLst/>
               <a:ahLst/>
               <a:cxnLst/>
-              <a:rect r="r" b="b" t="t" l="l"/>
+              <a:rect l="l" t="t" r="r" b="b"/>
               <a:pathLst>
-                <a:path h="2709333" w="3117343">
+                <a:path w="3117343" h="2709333">
                   <a:moveTo>
                     <a:pt x="0" y="0"/>
                   </a:moveTo>
@@ -4669,11 +4862,18 @@
               <a:srgbClr val="5A5A2C"/>
             </a:solidFill>
           </p:spPr>
+          <p:txBody>
+            <a:bodyPr/>
+            <a:lstStyle/>
+            <a:p>
+              <a:endParaRPr lang="en-US"/>
+            </a:p>
+          </p:txBody>
         </p:sp>
         <p:sp>
           <p:nvSpPr>
-            <p:cNvPr name="TextBox 4" id="4"/>
-            <p:cNvSpPr txBox="true"/>
+            <p:cNvPr id="4" name="TextBox 4"/>
+            <p:cNvSpPr txBox="1"/>
             <p:nvPr/>
           </p:nvSpPr>
           <p:spPr>
@@ -4686,7 +4886,7 @@
             </a:prstGeom>
           </p:spPr>
           <p:txBody>
-            <a:bodyPr anchor="ctr" rtlCol="false" tIns="50800" lIns="50800" bIns="50800" rIns="50800"/>
+            <a:bodyPr lIns="50800" tIns="50800" rIns="50800" bIns="50800" rtlCol="0" anchor="ctr"/>
             <a:lstStyle/>
             <a:p>
               <a:pPr algn="ctr">
@@ -4697,18 +4897,19 @@
                   <a:spcPct val="0"/>
                 </a:spcBef>
               </a:pPr>
+              <a:endParaRPr/>
             </a:p>
           </p:txBody>
         </p:sp>
       </p:grpSp>
       <p:sp>
         <p:nvSpPr>
-          <p:cNvPr name="Freeform 5" id="5"/>
+          <p:cNvPr id="5" name="Freeform 5"/>
           <p:cNvSpPr/>
           <p:nvPr/>
         </p:nvSpPr>
         <p:spPr>
-          <a:xfrm flipH="true" flipV="false" rot="-1114938">
+          <a:xfrm rot="-1114938" flipH="1">
             <a:off x="1829938" y="1864018"/>
             <a:ext cx="5610125" cy="6936785"/>
           </a:xfrm>
@@ -4717,9 +4918,9 @@
             <a:gdLst/>
             <a:ahLst/>
             <a:cxnLst/>
-            <a:rect r="r" b="b" t="t" l="l"/>
+            <a:rect l="l" t="t" r="r" b="b"/>
             <a:pathLst>
-              <a:path h="6936785" w="5610125">
+              <a:path w="5610125" h="6936785">
                 <a:moveTo>
                   <a:pt x="5610125" y="0"/>
                 </a:moveTo>
@@ -4742,19 +4943,26 @@
           <a:blipFill>
             <a:blip r:embed="rId2"/>
             <a:stretch>
-              <a:fillRect l="0" t="0" r="0" b="0"/>
+              <a:fillRect/>
             </a:stretch>
           </a:blipFill>
         </p:spPr>
-      </p:sp>
-      <p:sp>
-        <p:nvSpPr>
-          <p:cNvPr name="TextBox 6" id="6"/>
-          <p:cNvSpPr txBox="true"/>
+        <p:txBody>
+          <a:bodyPr/>
+          <a:lstStyle/>
+          <a:p>
+            <a:endParaRPr lang="en-US"/>
+          </a:p>
+        </p:txBody>
+      </p:sp>
+      <p:sp>
+        <p:nvSpPr>
+          <p:cNvPr id="6" name="TextBox 6"/>
+          <p:cNvSpPr txBox="1"/>
           <p:nvPr/>
         </p:nvSpPr>
         <p:spPr>
-          <a:xfrm rot="0">
+          <a:xfrm>
             <a:off x="8876226" y="1832652"/>
             <a:ext cx="6684591" cy="3000884"/>
           </a:xfrm>
@@ -4763,7 +4971,7 @@
           </a:prstGeom>
         </p:spPr>
         <p:txBody>
-          <a:bodyPr anchor="t" rtlCol="false" tIns="0" lIns="0" bIns="0" rIns="0">
+          <a:bodyPr lIns="0" tIns="0" rIns="0" bIns="0" rtlCol="0" anchor="t">
             <a:spAutoFit/>
           </a:bodyPr>
           <a:lstStyle/>
@@ -4783,43 +4991,19 @@
                 <a:cs typeface="Playfair Display"/>
                 <a:sym typeface="Playfair Display"/>
               </a:rPr>
-              <a:t>T</a:t>
-            </a:r>
-            <a:r>
-              <a:rPr lang="en-US" sz="8727">
-                <a:solidFill>
-                  <a:srgbClr val="F6F3E4"/>
-                </a:solidFill>
-                <a:latin typeface="Playfair Display"/>
-                <a:ea typeface="Playfair Display"/>
-                <a:cs typeface="Playfair Display"/>
-                <a:sym typeface="Playfair Display"/>
-              </a:rPr>
-              <a:t>echnisch</a:t>
-            </a:r>
-            <a:r>
-              <a:rPr lang="en-US" sz="8727">
-                <a:solidFill>
-                  <a:srgbClr val="F6F3E4"/>
-                </a:solidFill>
-                <a:latin typeface="Playfair Display"/>
-                <a:ea typeface="Playfair Display"/>
-                <a:cs typeface="Playfair Display"/>
-                <a:sym typeface="Playfair Display"/>
-              </a:rPr>
-              <a:t>er Aufbau</a:t>
-            </a:r>
-          </a:p>
-        </p:txBody>
-      </p:sp>
-      <p:sp>
-        <p:nvSpPr>
-          <p:cNvPr name="TextBox 7" id="7"/>
-          <p:cNvSpPr txBox="true"/>
+              <a:t>Technischer Aufbau</a:t>
+            </a:r>
+          </a:p>
+        </p:txBody>
+      </p:sp>
+      <p:sp>
+        <p:nvSpPr>
+          <p:cNvPr id="7" name="TextBox 7"/>
+          <p:cNvSpPr txBox="1"/>
           <p:nvPr/>
         </p:nvSpPr>
         <p:spPr>
-          <a:xfrm rot="0">
+          <a:xfrm>
             <a:off x="8876226" y="5330775"/>
             <a:ext cx="6987385" cy="2485399"/>
           </a:xfrm>
@@ -4828,7 +5012,7 @@
           </a:prstGeom>
         </p:spPr>
         <p:txBody>
-          <a:bodyPr anchor="t" rtlCol="false" tIns="0" lIns="0" bIns="0" rIns="0">
+          <a:bodyPr lIns="0" tIns="0" rIns="0" bIns="0" rtlCol="0" anchor="t">
             <a:spAutoFit/>
           </a:bodyPr>
           <a:lstStyle/>
@@ -4931,12 +5115,12 @@
       </p:sp>
       <p:sp>
         <p:nvSpPr>
-          <p:cNvPr name="Freeform 8" id="8"/>
+          <p:cNvPr id="8" name="Freeform 8"/>
           <p:cNvSpPr/>
           <p:nvPr/>
         </p:nvSpPr>
         <p:spPr>
-          <a:xfrm flipH="false" flipV="false" rot="0">
+          <a:xfrm>
             <a:off x="4635000" y="731433"/>
             <a:ext cx="1373001" cy="1048629"/>
           </a:xfrm>
@@ -4945,9 +5129,9 @@
             <a:gdLst/>
             <a:ahLst/>
             <a:cxnLst/>
-            <a:rect r="r" b="b" t="t" l="l"/>
+            <a:rect l="l" t="t" r="r" b="b"/>
             <a:pathLst>
-              <a:path h="1048629" w="1373001">
+              <a:path w="1373001" h="1048629">
                 <a:moveTo>
                   <a:pt x="0" y="0"/>
                 </a:moveTo>
@@ -4968,27 +5152,34 @@
             </a:pathLst>
           </a:custGeom>
           <a:blipFill>
-            <a:blip r:embed="rId3">
+            <a:blip>
               <a:extLst>
                 <a:ext uri="{96DAC541-7B7A-43D3-8B79-37D633B846F1}">
-                  <asvg:svgBlip xmlns:asvg="http://schemas.microsoft.com/office/drawing/2016/SVG/main" r:embed="rId4"/>
+                  <asvg:svgBlip xmlns:asvg="http://schemas.microsoft.com/office/drawing/2016/SVG/main" r:embed="rId3"/>
                 </a:ext>
               </a:extLst>
             </a:blip>
             <a:stretch>
-              <a:fillRect l="0" t="0" r="0" b="0"/>
+              <a:fillRect/>
             </a:stretch>
           </a:blipFill>
         </p:spPr>
-      </p:sp>
-      <p:sp>
-        <p:nvSpPr>
-          <p:cNvPr name="Freeform 9" id="9"/>
+        <p:txBody>
+          <a:bodyPr/>
+          <a:lstStyle/>
+          <a:p>
+            <a:endParaRPr lang="en-US"/>
+          </a:p>
+        </p:txBody>
+      </p:sp>
+      <p:sp>
+        <p:nvSpPr>
+          <p:cNvPr id="9" name="Freeform 9"/>
           <p:cNvSpPr/>
           <p:nvPr/>
         </p:nvSpPr>
         <p:spPr>
-          <a:xfrm flipH="false" flipV="false" rot="0">
+          <a:xfrm>
             <a:off x="1028700" y="7939752"/>
             <a:ext cx="1726413" cy="1318548"/>
           </a:xfrm>
@@ -4997,9 +5188,9 @@
             <a:gdLst/>
             <a:ahLst/>
             <a:cxnLst/>
-            <a:rect r="r" b="b" t="t" l="l"/>
+            <a:rect l="l" t="t" r="r" b="b"/>
             <a:pathLst>
-              <a:path h="1318548" w="1726413">
+              <a:path w="1726413" h="1318548">
                 <a:moveTo>
                   <a:pt x="0" y="0"/>
                 </a:moveTo>
@@ -5020,18 +5211,25 @@
             </a:pathLst>
           </a:custGeom>
           <a:blipFill>
-            <a:blip r:embed="rId3">
+            <a:blip>
               <a:extLst>
                 <a:ext uri="{96DAC541-7B7A-43D3-8B79-37D633B846F1}">
-                  <asvg:svgBlip xmlns:asvg="http://schemas.microsoft.com/office/drawing/2016/SVG/main" r:embed="rId4"/>
+                  <asvg:svgBlip xmlns:asvg="http://schemas.microsoft.com/office/drawing/2016/SVG/main" r:embed="rId3"/>
                 </a:ext>
               </a:extLst>
             </a:blip>
             <a:stretch>
-              <a:fillRect l="0" t="0" r="0" b="0"/>
+              <a:fillRect/>
             </a:stretch>
           </a:blipFill>
         </p:spPr>
+        <p:txBody>
+          <a:bodyPr/>
+          <a:lstStyle/>
+          <a:p>
+            <a:endParaRPr lang="en-US"/>
+          </a:p>
+        </p:txBody>
       </p:sp>
     </p:spTree>
   </p:cSld>
@@ -5042,13 +5240,14 @@
 </file>
 
 <file path=ppt/slides/slide5.xml><?xml version="1.0" encoding="utf-8"?>
-<p:sld xmlns:p="http://schemas.openxmlformats.org/presentationml/2006/main" xmlns:a="http://schemas.openxmlformats.org/drawingml/2006/main" xmlns:r="http://schemas.openxmlformats.org/officeDocument/2006/relationships">
+<p:sld xmlns:a="http://schemas.openxmlformats.org/drawingml/2006/main" xmlns:r="http://schemas.openxmlformats.org/officeDocument/2006/relationships" xmlns:p="http://schemas.openxmlformats.org/presentationml/2006/main">
   <p:cSld>
     <p:bg>
       <p:bgPr>
         <a:solidFill>
           <a:srgbClr val="F6F3E4"/>
         </a:solidFill>
+        <a:effectLst/>
       </p:bgPr>
     </p:bg>
     <p:spTree>
@@ -5067,12 +5266,12 @@
       </p:grpSpPr>
       <p:sp>
         <p:nvSpPr>
-          <p:cNvPr name="TextBox 2" id="2"/>
-          <p:cNvSpPr txBox="true"/>
+          <p:cNvPr id="2" name="TextBox 2"/>
+          <p:cNvSpPr txBox="1"/>
           <p:nvPr/>
         </p:nvSpPr>
         <p:spPr>
-          <a:xfrm rot="0">
+          <a:xfrm>
             <a:off x="4967619" y="4328858"/>
             <a:ext cx="8352763" cy="1476884"/>
           </a:xfrm>
@@ -5081,7 +5280,7 @@
           </a:prstGeom>
         </p:spPr>
         <p:txBody>
-          <a:bodyPr anchor="t" rtlCol="false" tIns="0" lIns="0" bIns="0" rIns="0">
+          <a:bodyPr lIns="0" tIns="0" rIns="0" bIns="0" rtlCol="0" anchor="t">
             <a:spAutoFit/>
           </a:bodyPr>
           <a:lstStyle/>
@@ -5108,12 +5307,12 @@
       </p:sp>
       <p:sp>
         <p:nvSpPr>
-          <p:cNvPr name="Freeform 3" id="3"/>
+          <p:cNvPr id="3" name="Freeform 3"/>
           <p:cNvSpPr/>
           <p:nvPr/>
         </p:nvSpPr>
         <p:spPr>
-          <a:xfrm flipH="true" flipV="false" rot="0">
+          <a:xfrm flipH="1">
             <a:off x="13854371" y="5755552"/>
             <a:ext cx="1726413" cy="1318548"/>
           </a:xfrm>
@@ -5122,9 +5321,9 @@
             <a:gdLst/>
             <a:ahLst/>
             <a:cxnLst/>
-            <a:rect r="r" b="b" t="t" l="l"/>
+            <a:rect l="l" t="t" r="r" b="b"/>
             <a:pathLst>
-              <a:path h="1318548" w="1726413">
+              <a:path w="1726413" h="1318548">
                 <a:moveTo>
                   <a:pt x="1726413" y="0"/>
                 </a:moveTo>
@@ -5145,27 +5344,34 @@
             </a:pathLst>
           </a:custGeom>
           <a:blipFill>
-            <a:blip r:embed="rId2">
+            <a:blip>
               <a:extLst>
                 <a:ext uri="{96DAC541-7B7A-43D3-8B79-37D633B846F1}">
-                  <asvg:svgBlip xmlns:asvg="http://schemas.microsoft.com/office/drawing/2016/SVG/main" r:embed="rId3"/>
+                  <asvg:svgBlip xmlns:asvg="http://schemas.microsoft.com/office/drawing/2016/SVG/main" r:embed="rId2"/>
                 </a:ext>
               </a:extLst>
             </a:blip>
             <a:stretch>
-              <a:fillRect l="0" t="0" r="0" b="0"/>
+              <a:fillRect/>
             </a:stretch>
           </a:blipFill>
         </p:spPr>
-      </p:sp>
-      <p:sp>
-        <p:nvSpPr>
-          <p:cNvPr name="Freeform 4" id="4"/>
+        <p:txBody>
+          <a:bodyPr/>
+          <a:lstStyle/>
+          <a:p>
+            <a:endParaRPr lang="en-US"/>
+          </a:p>
+        </p:txBody>
+      </p:sp>
+      <p:sp>
+        <p:nvSpPr>
+          <p:cNvPr id="4" name="Freeform 4"/>
           <p:cNvSpPr/>
           <p:nvPr/>
         </p:nvSpPr>
         <p:spPr>
-          <a:xfrm flipH="false" flipV="false" rot="0">
+          <a:xfrm>
             <a:off x="3418501" y="1900608"/>
             <a:ext cx="1648591" cy="1259111"/>
           </a:xfrm>
@@ -5174,9 +5380,9 @@
             <a:gdLst/>
             <a:ahLst/>
             <a:cxnLst/>
-            <a:rect r="r" b="b" t="t" l="l"/>
+            <a:rect l="l" t="t" r="r" b="b"/>
             <a:pathLst>
-              <a:path h="1259111" w="1648591">
+              <a:path w="1648591" h="1259111">
                 <a:moveTo>
                   <a:pt x="0" y="0"/>
                 </a:moveTo>
@@ -5197,27 +5403,34 @@
             </a:pathLst>
           </a:custGeom>
           <a:blipFill>
-            <a:blip r:embed="rId2">
+            <a:blip>
               <a:extLst>
                 <a:ext uri="{96DAC541-7B7A-43D3-8B79-37D633B846F1}">
-                  <asvg:svgBlip xmlns:asvg="http://schemas.microsoft.com/office/drawing/2016/SVG/main" r:embed="rId3"/>
+                  <asvg:svgBlip xmlns:asvg="http://schemas.microsoft.com/office/drawing/2016/SVG/main" r:embed="rId2"/>
                 </a:ext>
               </a:extLst>
             </a:blip>
             <a:stretch>
-              <a:fillRect l="0" t="0" r="0" b="0"/>
+              <a:fillRect/>
             </a:stretch>
           </a:blipFill>
         </p:spPr>
-      </p:sp>
-      <p:sp>
-        <p:nvSpPr>
-          <p:cNvPr name="Freeform 5" id="5"/>
+        <p:txBody>
+          <a:bodyPr/>
+          <a:lstStyle/>
+          <a:p>
+            <a:endParaRPr lang="en-US"/>
+          </a:p>
+        </p:txBody>
+      </p:sp>
+      <p:sp>
+        <p:nvSpPr>
+          <p:cNvPr id="5" name="Freeform 5"/>
           <p:cNvSpPr/>
           <p:nvPr/>
         </p:nvSpPr>
         <p:spPr>
-          <a:xfrm flipH="false" flipV="false" rot="2589396">
+          <a:xfrm rot="2589396">
             <a:off x="-900555" y="1971844"/>
             <a:ext cx="2605102" cy="3345235"/>
           </a:xfrm>
@@ -5226,9 +5439,9 @@
             <a:gdLst/>
             <a:ahLst/>
             <a:cxnLst/>
-            <a:rect r="r" b="b" t="t" l="l"/>
+            <a:rect l="l" t="t" r="r" b="b"/>
             <a:pathLst>
-              <a:path h="3345235" w="2605102">
+              <a:path w="2605102" h="3345235">
                 <a:moveTo>
                   <a:pt x="0" y="0"/>
                 </a:moveTo>
@@ -5240,6 +5453,59 @@
                 </a:lnTo>
                 <a:lnTo>
                   <a:pt x="0" y="3345235"/>
+                </a:lnTo>
+                <a:lnTo>
+                  <a:pt x="0" y="0"/>
+                </a:lnTo>
+                <a:close/>
+              </a:path>
+            </a:pathLst>
+          </a:custGeom>
+          <a:blipFill>
+            <a:blip r:embed="rId3"/>
+            <a:stretch>
+              <a:fillRect/>
+            </a:stretch>
+          </a:blipFill>
+        </p:spPr>
+        <p:txBody>
+          <a:bodyPr/>
+          <a:lstStyle/>
+          <a:p>
+            <a:endParaRPr lang="en-US"/>
+          </a:p>
+        </p:txBody>
+      </p:sp>
+      <p:sp>
+        <p:nvSpPr>
+          <p:cNvPr id="6" name="Freeform 6"/>
+          <p:cNvSpPr/>
+          <p:nvPr/>
+        </p:nvSpPr>
+        <p:spPr>
+          <a:xfrm>
+            <a:off x="13874648" y="6868216"/>
+            <a:ext cx="5644997" cy="2878949"/>
+          </a:xfrm>
+          <a:custGeom>
+            <a:avLst/>
+            <a:gdLst/>
+            <a:ahLst/>
+            <a:cxnLst/>
+            <a:rect l="l" t="t" r="r" b="b"/>
+            <a:pathLst>
+              <a:path w="5644997" h="2878949">
+                <a:moveTo>
+                  <a:pt x="0" y="0"/>
+                </a:moveTo>
+                <a:lnTo>
+                  <a:pt x="5644997" y="0"/>
+                </a:lnTo>
+                <a:lnTo>
+                  <a:pt x="5644997" y="2878949"/>
+                </a:lnTo>
+                <a:lnTo>
+                  <a:pt x="0" y="2878949"/>
                 </a:lnTo>
                 <a:lnTo>
                   <a:pt x="0" y="0"/>
@@ -5251,41 +5517,48 @@
           <a:blipFill>
             <a:blip r:embed="rId4"/>
             <a:stretch>
-              <a:fillRect l="0" t="0" r="0" b="0"/>
+              <a:fillRect/>
             </a:stretch>
           </a:blipFill>
         </p:spPr>
-      </p:sp>
-      <p:sp>
-        <p:nvSpPr>
-          <p:cNvPr name="Freeform 6" id="6"/>
+        <p:txBody>
+          <a:bodyPr/>
+          <a:lstStyle/>
+          <a:p>
+            <a:endParaRPr lang="en-US"/>
+          </a:p>
+        </p:txBody>
+      </p:sp>
+      <p:sp>
+        <p:nvSpPr>
+          <p:cNvPr id="7" name="Freeform 7"/>
           <p:cNvSpPr/>
           <p:nvPr/>
         </p:nvSpPr>
         <p:spPr>
-          <a:xfrm flipH="false" flipV="false" rot="0">
-            <a:off x="13874648" y="6868216"/>
-            <a:ext cx="5644997" cy="2878949"/>
+          <a:xfrm>
+            <a:off x="1362551" y="7074100"/>
+            <a:ext cx="3453671" cy="4780167"/>
           </a:xfrm>
           <a:custGeom>
             <a:avLst/>
             <a:gdLst/>
             <a:ahLst/>
             <a:cxnLst/>
-            <a:rect r="r" b="b" t="t" l="l"/>
+            <a:rect l="l" t="t" r="r" b="b"/>
             <a:pathLst>
-              <a:path h="2878949" w="5644997">
+              <a:path w="3453671" h="4780167">
                 <a:moveTo>
                   <a:pt x="0" y="0"/>
                 </a:moveTo>
                 <a:lnTo>
-                  <a:pt x="5644997" y="0"/>
-                </a:lnTo>
-                <a:lnTo>
-                  <a:pt x="5644997" y="2878949"/>
-                </a:lnTo>
-                <a:lnTo>
-                  <a:pt x="0" y="2878949"/>
+                  <a:pt x="3453671" y="0"/>
+                </a:lnTo>
+                <a:lnTo>
+                  <a:pt x="3453671" y="4780167"/>
+                </a:lnTo>
+                <a:lnTo>
+                  <a:pt x="0" y="4780167"/>
                 </a:lnTo>
                 <a:lnTo>
                   <a:pt x="0" y="0"/>
@@ -5297,41 +5570,48 @@
           <a:blipFill>
             <a:blip r:embed="rId5"/>
             <a:stretch>
-              <a:fillRect l="0" t="0" r="0" b="0"/>
+              <a:fillRect/>
             </a:stretch>
           </a:blipFill>
         </p:spPr>
-      </p:sp>
-      <p:sp>
-        <p:nvSpPr>
-          <p:cNvPr name="Freeform 7" id="7"/>
+        <p:txBody>
+          <a:bodyPr/>
+          <a:lstStyle/>
+          <a:p>
+            <a:endParaRPr lang="en-US"/>
+          </a:p>
+        </p:txBody>
+      </p:sp>
+      <p:sp>
+        <p:nvSpPr>
+          <p:cNvPr id="8" name="Freeform 8"/>
           <p:cNvSpPr/>
           <p:nvPr/>
         </p:nvSpPr>
         <p:spPr>
-          <a:xfrm flipH="false" flipV="false" rot="0">
-            <a:off x="1362551" y="7074100"/>
-            <a:ext cx="3453671" cy="4780167"/>
+          <a:xfrm>
+            <a:off x="13129385" y="-571642"/>
+            <a:ext cx="4129915" cy="3200684"/>
           </a:xfrm>
           <a:custGeom>
             <a:avLst/>
             <a:gdLst/>
             <a:ahLst/>
             <a:cxnLst/>
-            <a:rect r="r" b="b" t="t" l="l"/>
+            <a:rect l="l" t="t" r="r" b="b"/>
             <a:pathLst>
-              <a:path h="4780167" w="3453671">
+              <a:path w="4129915" h="3200684">
                 <a:moveTo>
                   <a:pt x="0" y="0"/>
                 </a:moveTo>
                 <a:lnTo>
-                  <a:pt x="3453671" y="0"/>
-                </a:lnTo>
-                <a:lnTo>
-                  <a:pt x="3453671" y="4780167"/>
-                </a:lnTo>
-                <a:lnTo>
-                  <a:pt x="0" y="4780167"/>
+                  <a:pt x="4129915" y="0"/>
+                </a:lnTo>
+                <a:lnTo>
+                  <a:pt x="4129915" y="3200684"/>
+                </a:lnTo>
+                <a:lnTo>
+                  <a:pt x="0" y="3200684"/>
                 </a:lnTo>
                 <a:lnTo>
                   <a:pt x="0" y="0"/>
@@ -5343,56 +5623,17 @@
           <a:blipFill>
             <a:blip r:embed="rId6"/>
             <a:stretch>
-              <a:fillRect l="0" t="0" r="0" b="0"/>
+              <a:fillRect/>
             </a:stretch>
           </a:blipFill>
         </p:spPr>
-      </p:sp>
-      <p:sp>
-        <p:nvSpPr>
-          <p:cNvPr name="Freeform 8" id="8"/>
-          <p:cNvSpPr/>
-          <p:nvPr/>
-        </p:nvSpPr>
-        <p:spPr>
-          <a:xfrm flipH="false" flipV="false" rot="0">
-            <a:off x="13129385" y="-571642"/>
-            <a:ext cx="4129915" cy="3200684"/>
-          </a:xfrm>
-          <a:custGeom>
-            <a:avLst/>
-            <a:gdLst/>
-            <a:ahLst/>
-            <a:cxnLst/>
-            <a:rect r="r" b="b" t="t" l="l"/>
-            <a:pathLst>
-              <a:path h="3200684" w="4129915">
-                <a:moveTo>
-                  <a:pt x="0" y="0"/>
-                </a:moveTo>
-                <a:lnTo>
-                  <a:pt x="4129915" y="0"/>
-                </a:lnTo>
-                <a:lnTo>
-                  <a:pt x="4129915" y="3200684"/>
-                </a:lnTo>
-                <a:lnTo>
-                  <a:pt x="0" y="3200684"/>
-                </a:lnTo>
-                <a:lnTo>
-                  <a:pt x="0" y="0"/>
-                </a:lnTo>
-                <a:close/>
-              </a:path>
-            </a:pathLst>
-          </a:custGeom>
-          <a:blipFill>
-            <a:blip r:embed="rId7"/>
-            <a:stretch>
-              <a:fillRect l="0" t="0" r="0" b="0"/>
-            </a:stretch>
-          </a:blipFill>
-        </p:spPr>
+        <p:txBody>
+          <a:bodyPr/>
+          <a:lstStyle/>
+          <a:p>
+            <a:endParaRPr lang="en-US"/>
+          </a:p>
+        </p:txBody>
       </p:sp>
     </p:spTree>
   </p:cSld>
@@ -5403,13 +5644,14 @@
 </file>
 
 <file path=ppt/slides/slide6.xml><?xml version="1.0" encoding="utf-8"?>
-<p:sld xmlns:p="http://schemas.openxmlformats.org/presentationml/2006/main" xmlns:a="http://schemas.openxmlformats.org/drawingml/2006/main" xmlns:r="http://schemas.openxmlformats.org/officeDocument/2006/relationships">
+<p:sld xmlns:a="http://schemas.openxmlformats.org/drawingml/2006/main" xmlns:r="http://schemas.openxmlformats.org/officeDocument/2006/relationships" xmlns:p="http://schemas.openxmlformats.org/presentationml/2006/main">
   <p:cSld>
     <p:bg>
       <p:bgPr>
         <a:solidFill>
           <a:srgbClr val="F6F3E4"/>
         </a:solidFill>
+        <a:effectLst/>
       </p:bgPr>
     </p:bg>
     <p:spTree>
@@ -5428,12 +5670,12 @@
       </p:grpSpPr>
       <p:grpSp>
         <p:nvGrpSpPr>
-          <p:cNvPr name="Group 2" id="2"/>
+          <p:cNvPr id="2" name="Group 2"/>
           <p:cNvGrpSpPr/>
           <p:nvPr/>
         </p:nvGrpSpPr>
         <p:grpSpPr>
-          <a:xfrm rot="0">
+          <a:xfrm>
             <a:off x="6451837" y="0"/>
             <a:ext cx="11836163" cy="10287000"/>
             <a:chOff x="0" y="0"/>
@@ -5442,12 +5684,12 @@
         </p:grpSpPr>
         <p:sp>
           <p:nvSpPr>
-            <p:cNvPr name="Freeform 3" id="3"/>
+            <p:cNvPr id="3" name="Freeform 3"/>
             <p:cNvSpPr/>
             <p:nvPr/>
           </p:nvSpPr>
           <p:spPr>
-            <a:xfrm flipH="false" flipV="false" rot="0">
+            <a:xfrm>
               <a:off x="0" y="0"/>
               <a:ext cx="3117343" cy="2709333"/>
             </a:xfrm>
@@ -5456,9 +5698,9 @@
               <a:gdLst/>
               <a:ahLst/>
               <a:cxnLst/>
-              <a:rect r="r" b="b" t="t" l="l"/>
+              <a:rect l="l" t="t" r="r" b="b"/>
               <a:pathLst>
-                <a:path h="2709333" w="3117343">
+                <a:path w="3117343" h="2709333">
                   <a:moveTo>
                     <a:pt x="0" y="0"/>
                   </a:moveTo>
@@ -5479,11 +5721,18 @@
               <a:srgbClr val="5A5A2C"/>
             </a:solidFill>
           </p:spPr>
+          <p:txBody>
+            <a:bodyPr/>
+            <a:lstStyle/>
+            <a:p>
+              <a:endParaRPr lang="en-US"/>
+            </a:p>
+          </p:txBody>
         </p:sp>
         <p:sp>
           <p:nvSpPr>
-            <p:cNvPr name="TextBox 4" id="4"/>
-            <p:cNvSpPr txBox="true"/>
+            <p:cNvPr id="4" name="TextBox 4"/>
+            <p:cNvSpPr txBox="1"/>
             <p:nvPr/>
           </p:nvSpPr>
           <p:spPr>
@@ -5496,7 +5745,7 @@
             </a:prstGeom>
           </p:spPr>
           <p:txBody>
-            <a:bodyPr anchor="ctr" rtlCol="false" tIns="50800" lIns="50800" bIns="50800" rIns="50800"/>
+            <a:bodyPr lIns="50800" tIns="50800" rIns="50800" bIns="50800" rtlCol="0" anchor="ctr"/>
             <a:lstStyle/>
             <a:p>
               <a:pPr algn="ctr">
@@ -5507,18 +5756,19 @@
                   <a:spcPct val="0"/>
                 </a:spcBef>
               </a:pPr>
+              <a:endParaRPr/>
             </a:p>
           </p:txBody>
         </p:sp>
       </p:grpSp>
       <p:sp>
         <p:nvSpPr>
-          <p:cNvPr name="Freeform 5" id="5"/>
+          <p:cNvPr id="5" name="Freeform 5"/>
           <p:cNvSpPr/>
           <p:nvPr/>
         </p:nvSpPr>
         <p:spPr>
-          <a:xfrm flipH="false" flipV="false" rot="0">
+          <a:xfrm>
             <a:off x="4635000" y="731433"/>
             <a:ext cx="1373001" cy="1048629"/>
           </a:xfrm>
@@ -5527,9 +5777,9 @@
             <a:gdLst/>
             <a:ahLst/>
             <a:cxnLst/>
-            <a:rect r="r" b="b" t="t" l="l"/>
+            <a:rect l="l" t="t" r="r" b="b"/>
             <a:pathLst>
-              <a:path h="1048629" w="1373001">
+              <a:path w="1373001" h="1048629">
                 <a:moveTo>
                   <a:pt x="0" y="0"/>
                 </a:moveTo>
@@ -5550,27 +5800,34 @@
             </a:pathLst>
           </a:custGeom>
           <a:blipFill>
-            <a:blip r:embed="rId2">
+            <a:blip>
               <a:extLst>
                 <a:ext uri="{96DAC541-7B7A-43D3-8B79-37D633B846F1}">
-                  <asvg:svgBlip xmlns:asvg="http://schemas.microsoft.com/office/drawing/2016/SVG/main" r:embed="rId3"/>
+                  <asvg:svgBlip xmlns:asvg="http://schemas.microsoft.com/office/drawing/2016/SVG/main" r:embed="rId2"/>
                 </a:ext>
               </a:extLst>
             </a:blip>
             <a:stretch>
-              <a:fillRect l="0" t="0" r="0" b="0"/>
+              <a:fillRect/>
             </a:stretch>
           </a:blipFill>
         </p:spPr>
-      </p:sp>
-      <p:sp>
-        <p:nvSpPr>
-          <p:cNvPr name="Freeform 6" id="6"/>
+        <p:txBody>
+          <a:bodyPr/>
+          <a:lstStyle/>
+          <a:p>
+            <a:endParaRPr lang="en-US"/>
+          </a:p>
+        </p:txBody>
+      </p:sp>
+      <p:sp>
+        <p:nvSpPr>
+          <p:cNvPr id="6" name="Freeform 6"/>
           <p:cNvSpPr/>
           <p:nvPr/>
         </p:nvSpPr>
         <p:spPr>
-          <a:xfrm flipH="false" flipV="false" rot="0">
+          <a:xfrm>
             <a:off x="1028700" y="7939752"/>
             <a:ext cx="1726413" cy="1318548"/>
           </a:xfrm>
@@ -5579,9 +5836,9 @@
             <a:gdLst/>
             <a:ahLst/>
             <a:cxnLst/>
-            <a:rect r="r" b="b" t="t" l="l"/>
+            <a:rect l="l" t="t" r="r" b="b"/>
             <a:pathLst>
-              <a:path h="1318548" w="1726413">
+              <a:path w="1726413" h="1318548">
                 <a:moveTo>
                   <a:pt x="0" y="0"/>
                 </a:moveTo>
@@ -5602,27 +5859,34 @@
             </a:pathLst>
           </a:custGeom>
           <a:blipFill>
-            <a:blip r:embed="rId2">
+            <a:blip>
               <a:extLst>
                 <a:ext uri="{96DAC541-7B7A-43D3-8B79-37D633B846F1}">
-                  <asvg:svgBlip xmlns:asvg="http://schemas.microsoft.com/office/drawing/2016/SVG/main" r:embed="rId3"/>
+                  <asvg:svgBlip xmlns:asvg="http://schemas.microsoft.com/office/drawing/2016/SVG/main" r:embed="rId2"/>
                 </a:ext>
               </a:extLst>
             </a:blip>
             <a:stretch>
-              <a:fillRect l="0" t="0" r="0" b="0"/>
+              <a:fillRect/>
             </a:stretch>
           </a:blipFill>
         </p:spPr>
-      </p:sp>
-      <p:sp>
-        <p:nvSpPr>
-          <p:cNvPr name="Freeform 7" id="7"/>
+        <p:txBody>
+          <a:bodyPr/>
+          <a:lstStyle/>
+          <a:p>
+            <a:endParaRPr lang="en-US"/>
+          </a:p>
+        </p:txBody>
+      </p:sp>
+      <p:sp>
+        <p:nvSpPr>
+          <p:cNvPr id="7" name="Freeform 7"/>
           <p:cNvSpPr/>
           <p:nvPr/>
         </p:nvSpPr>
         <p:spPr>
-          <a:xfrm flipH="false" flipV="false" rot="0">
+          <a:xfrm>
             <a:off x="572274" y="2590655"/>
             <a:ext cx="7635336" cy="4485760"/>
           </a:xfrm>
@@ -5631,9 +5895,9 @@
             <a:gdLst/>
             <a:ahLst/>
             <a:cxnLst/>
-            <a:rect r="r" b="b" t="t" l="l"/>
+            <a:rect l="l" t="t" r="r" b="b"/>
             <a:pathLst>
-              <a:path h="4485760" w="7635336">
+              <a:path w="7635336" h="4485760">
                 <a:moveTo>
                   <a:pt x="0" y="0"/>
                 </a:moveTo>
@@ -5645,6 +5909,59 @@
                 </a:lnTo>
                 <a:lnTo>
                   <a:pt x="0" y="4485760"/>
+                </a:lnTo>
+                <a:lnTo>
+                  <a:pt x="0" y="0"/>
+                </a:lnTo>
+                <a:close/>
+              </a:path>
+            </a:pathLst>
+          </a:custGeom>
+          <a:blipFill>
+            <a:blip r:embed="rId3"/>
+            <a:stretch>
+              <a:fillRect/>
+            </a:stretch>
+          </a:blipFill>
+        </p:spPr>
+        <p:txBody>
+          <a:bodyPr/>
+          <a:lstStyle/>
+          <a:p>
+            <a:endParaRPr lang="en-US"/>
+          </a:p>
+        </p:txBody>
+      </p:sp>
+      <p:sp>
+        <p:nvSpPr>
+          <p:cNvPr id="8" name="Freeform 8"/>
+          <p:cNvSpPr/>
+          <p:nvPr/>
+        </p:nvSpPr>
+        <p:spPr>
+          <a:xfrm>
+            <a:off x="6719289" y="518783"/>
+            <a:ext cx="11301259" cy="3164353"/>
+          </a:xfrm>
+          <a:custGeom>
+            <a:avLst/>
+            <a:gdLst/>
+            <a:ahLst/>
+            <a:cxnLst/>
+            <a:rect l="l" t="t" r="r" b="b"/>
+            <a:pathLst>
+              <a:path w="11301259" h="3164353">
+                <a:moveTo>
+                  <a:pt x="0" y="0"/>
+                </a:moveTo>
+                <a:lnTo>
+                  <a:pt x="11301259" y="0"/>
+                </a:lnTo>
+                <a:lnTo>
+                  <a:pt x="11301259" y="3164353"/>
+                </a:lnTo>
+                <a:lnTo>
+                  <a:pt x="0" y="3164353"/>
                 </a:lnTo>
                 <a:lnTo>
                   <a:pt x="0" y="0"/>
@@ -5656,30 +5973,37 @@
           <a:blipFill>
             <a:blip r:embed="rId4"/>
             <a:stretch>
-              <a:fillRect l="0" t="0" r="0" b="0"/>
+              <a:fillRect/>
             </a:stretch>
           </a:blipFill>
         </p:spPr>
-      </p:sp>
-      <p:sp>
-        <p:nvSpPr>
-          <p:cNvPr name="Freeform 8" id="8"/>
+        <p:txBody>
+          <a:bodyPr/>
+          <a:lstStyle/>
+          <a:p>
+            <a:endParaRPr lang="en-US"/>
+          </a:p>
+        </p:txBody>
+      </p:sp>
+      <p:sp>
+        <p:nvSpPr>
+          <p:cNvPr id="9" name="Freeform 9"/>
           <p:cNvSpPr/>
           <p:nvPr/>
         </p:nvSpPr>
         <p:spPr>
-          <a:xfrm flipH="false" flipV="false" rot="0">
-            <a:off x="6719289" y="518783"/>
-            <a:ext cx="11301259" cy="3164353"/>
+          <a:xfrm>
+            <a:off x="6719289" y="5143500"/>
+            <a:ext cx="11301259" cy="4845415"/>
           </a:xfrm>
           <a:custGeom>
             <a:avLst/>
             <a:gdLst/>
             <a:ahLst/>
             <a:cxnLst/>
-            <a:rect r="r" b="b" t="t" l="l"/>
+            <a:rect l="l" t="t" r="r" b="b"/>
             <a:pathLst>
-              <a:path h="3164353" w="11301259">
+              <a:path w="11301259" h="4845415">
                 <a:moveTo>
                   <a:pt x="0" y="0"/>
                 </a:moveTo>
@@ -5687,10 +6011,10 @@
                   <a:pt x="11301259" y="0"/>
                 </a:lnTo>
                 <a:lnTo>
-                  <a:pt x="11301259" y="3164353"/>
-                </a:lnTo>
-                <a:lnTo>
-                  <a:pt x="0" y="3164353"/>
+                  <a:pt x="11301259" y="4845415"/>
+                </a:lnTo>
+                <a:lnTo>
+                  <a:pt x="0" y="4845415"/>
                 </a:lnTo>
                 <a:lnTo>
                   <a:pt x="0" y="0"/>
@@ -5702,56 +6026,17 @@
           <a:blipFill>
             <a:blip r:embed="rId5"/>
             <a:stretch>
-              <a:fillRect l="0" t="0" r="0" b="0"/>
+              <a:fillRect/>
             </a:stretch>
           </a:blipFill>
         </p:spPr>
-      </p:sp>
-      <p:sp>
-        <p:nvSpPr>
-          <p:cNvPr name="Freeform 9" id="9"/>
-          <p:cNvSpPr/>
-          <p:nvPr/>
-        </p:nvSpPr>
-        <p:spPr>
-          <a:xfrm flipH="false" flipV="false" rot="0">
-            <a:off x="6719289" y="5143500"/>
-            <a:ext cx="11301259" cy="4845415"/>
-          </a:xfrm>
-          <a:custGeom>
-            <a:avLst/>
-            <a:gdLst/>
-            <a:ahLst/>
-            <a:cxnLst/>
-            <a:rect r="r" b="b" t="t" l="l"/>
-            <a:pathLst>
-              <a:path h="4845415" w="11301259">
-                <a:moveTo>
-                  <a:pt x="0" y="0"/>
-                </a:moveTo>
-                <a:lnTo>
-                  <a:pt x="11301259" y="0"/>
-                </a:lnTo>
-                <a:lnTo>
-                  <a:pt x="11301259" y="4845415"/>
-                </a:lnTo>
-                <a:lnTo>
-                  <a:pt x="0" y="4845415"/>
-                </a:lnTo>
-                <a:lnTo>
-                  <a:pt x="0" y="0"/>
-                </a:lnTo>
-                <a:close/>
-              </a:path>
-            </a:pathLst>
-          </a:custGeom>
-          <a:blipFill>
-            <a:blip r:embed="rId6"/>
-            <a:stretch>
-              <a:fillRect l="0" t="0" r="0" b="0"/>
-            </a:stretch>
-          </a:blipFill>
-        </p:spPr>
+        <p:txBody>
+          <a:bodyPr/>
+          <a:lstStyle/>
+          <a:p>
+            <a:endParaRPr lang="en-US"/>
+          </a:p>
+        </p:txBody>
       </p:sp>
     </p:spTree>
   </p:cSld>
@@ -5762,13 +6047,14 @@
 </file>
 
 <file path=ppt/slides/slide7.xml><?xml version="1.0" encoding="utf-8"?>
-<p:sld xmlns:p="http://schemas.openxmlformats.org/presentationml/2006/main" xmlns:a="http://schemas.openxmlformats.org/drawingml/2006/main" xmlns:r="http://schemas.openxmlformats.org/officeDocument/2006/relationships">
+<p:sld xmlns:a="http://schemas.openxmlformats.org/drawingml/2006/main" xmlns:r="http://schemas.openxmlformats.org/officeDocument/2006/relationships" xmlns:p="http://schemas.openxmlformats.org/presentationml/2006/main">
   <p:cSld>
     <p:bg>
       <p:bgPr>
         <a:solidFill>
           <a:srgbClr val="F6F3E4"/>
         </a:solidFill>
+        <a:effectLst/>
       </p:bgPr>
     </p:bg>
     <p:spTree>
@@ -5787,12 +6073,12 @@
       </p:grpSpPr>
       <p:grpSp>
         <p:nvGrpSpPr>
-          <p:cNvPr name="Group 2" id="2"/>
+          <p:cNvPr id="2" name="Group 2"/>
           <p:cNvGrpSpPr/>
           <p:nvPr/>
         </p:nvGrpSpPr>
         <p:grpSpPr>
-          <a:xfrm rot="0">
+          <a:xfrm>
             <a:off x="6451837" y="0"/>
             <a:ext cx="11836163" cy="10287000"/>
             <a:chOff x="0" y="0"/>
@@ -5801,12 +6087,12 @@
         </p:grpSpPr>
         <p:sp>
           <p:nvSpPr>
-            <p:cNvPr name="Freeform 3" id="3"/>
+            <p:cNvPr id="3" name="Freeform 3"/>
             <p:cNvSpPr/>
             <p:nvPr/>
           </p:nvSpPr>
           <p:spPr>
-            <a:xfrm flipH="false" flipV="false" rot="0">
+            <a:xfrm>
               <a:off x="0" y="0"/>
               <a:ext cx="3117343" cy="2709333"/>
             </a:xfrm>
@@ -5815,9 +6101,9 @@
               <a:gdLst/>
               <a:ahLst/>
               <a:cxnLst/>
-              <a:rect r="r" b="b" t="t" l="l"/>
+              <a:rect l="l" t="t" r="r" b="b"/>
               <a:pathLst>
-                <a:path h="2709333" w="3117343">
+                <a:path w="3117343" h="2709333">
                   <a:moveTo>
                     <a:pt x="0" y="0"/>
                   </a:moveTo>
@@ -5838,11 +6124,18 @@
               <a:srgbClr val="5A5A2C"/>
             </a:solidFill>
           </p:spPr>
+          <p:txBody>
+            <a:bodyPr/>
+            <a:lstStyle/>
+            <a:p>
+              <a:endParaRPr lang="en-US"/>
+            </a:p>
+          </p:txBody>
         </p:sp>
         <p:sp>
           <p:nvSpPr>
-            <p:cNvPr name="TextBox 4" id="4"/>
-            <p:cNvSpPr txBox="true"/>
+            <p:cNvPr id="4" name="TextBox 4"/>
+            <p:cNvSpPr txBox="1"/>
             <p:nvPr/>
           </p:nvSpPr>
           <p:spPr>
@@ -5855,7 +6148,7 @@
             </a:prstGeom>
           </p:spPr>
           <p:txBody>
-            <a:bodyPr anchor="ctr" rtlCol="false" tIns="50800" lIns="50800" bIns="50800" rIns="50800"/>
+            <a:bodyPr lIns="50800" tIns="50800" rIns="50800" bIns="50800" rtlCol="0" anchor="ctr"/>
             <a:lstStyle/>
             <a:p>
               <a:pPr algn="ctr">
@@ -5866,18 +6159,19 @@
                   <a:spcPct val="0"/>
                 </a:spcBef>
               </a:pPr>
+              <a:endParaRPr/>
             </a:p>
           </p:txBody>
         </p:sp>
       </p:grpSp>
       <p:sp>
         <p:nvSpPr>
-          <p:cNvPr name="Freeform 5" id="5"/>
+          <p:cNvPr id="5" name="Freeform 5"/>
           <p:cNvSpPr/>
           <p:nvPr/>
         </p:nvSpPr>
         <p:spPr>
-          <a:xfrm flipH="false" flipV="false" rot="0">
+          <a:xfrm>
             <a:off x="4635000" y="731433"/>
             <a:ext cx="1373001" cy="1048629"/>
           </a:xfrm>
@@ -5886,9 +6180,9 @@
             <a:gdLst/>
             <a:ahLst/>
             <a:cxnLst/>
-            <a:rect r="r" b="b" t="t" l="l"/>
+            <a:rect l="l" t="t" r="r" b="b"/>
             <a:pathLst>
-              <a:path h="1048629" w="1373001">
+              <a:path w="1373001" h="1048629">
                 <a:moveTo>
                   <a:pt x="0" y="0"/>
                 </a:moveTo>
@@ -5909,27 +6203,34 @@
             </a:pathLst>
           </a:custGeom>
           <a:blipFill>
-            <a:blip r:embed="rId2">
+            <a:blip>
               <a:extLst>
                 <a:ext uri="{96DAC541-7B7A-43D3-8B79-37D633B846F1}">
-                  <asvg:svgBlip xmlns:asvg="http://schemas.microsoft.com/office/drawing/2016/SVG/main" r:embed="rId3"/>
+                  <asvg:svgBlip xmlns:asvg="http://schemas.microsoft.com/office/drawing/2016/SVG/main" r:embed="rId2"/>
                 </a:ext>
               </a:extLst>
             </a:blip>
             <a:stretch>
-              <a:fillRect l="0" t="0" r="0" b="0"/>
+              <a:fillRect/>
             </a:stretch>
           </a:blipFill>
         </p:spPr>
-      </p:sp>
-      <p:sp>
-        <p:nvSpPr>
-          <p:cNvPr name="Freeform 6" id="6"/>
+        <p:txBody>
+          <a:bodyPr/>
+          <a:lstStyle/>
+          <a:p>
+            <a:endParaRPr lang="en-US"/>
+          </a:p>
+        </p:txBody>
+      </p:sp>
+      <p:sp>
+        <p:nvSpPr>
+          <p:cNvPr id="6" name="Freeform 6"/>
           <p:cNvSpPr/>
           <p:nvPr/>
         </p:nvSpPr>
         <p:spPr>
-          <a:xfrm flipH="false" flipV="false" rot="0">
+          <a:xfrm>
             <a:off x="1028700" y="7939752"/>
             <a:ext cx="1726413" cy="1318548"/>
           </a:xfrm>
@@ -5938,9 +6239,9 @@
             <a:gdLst/>
             <a:ahLst/>
             <a:cxnLst/>
-            <a:rect r="r" b="b" t="t" l="l"/>
+            <a:rect l="l" t="t" r="r" b="b"/>
             <a:pathLst>
-              <a:path h="1318548" w="1726413">
+              <a:path w="1726413" h="1318548">
                 <a:moveTo>
                   <a:pt x="0" y="0"/>
                 </a:moveTo>
@@ -5961,27 +6262,34 @@
             </a:pathLst>
           </a:custGeom>
           <a:blipFill>
-            <a:blip r:embed="rId2">
+            <a:blip>
               <a:extLst>
                 <a:ext uri="{96DAC541-7B7A-43D3-8B79-37D633B846F1}">
-                  <asvg:svgBlip xmlns:asvg="http://schemas.microsoft.com/office/drawing/2016/SVG/main" r:embed="rId3"/>
+                  <asvg:svgBlip xmlns:asvg="http://schemas.microsoft.com/office/drawing/2016/SVG/main" r:embed="rId2"/>
                 </a:ext>
               </a:extLst>
             </a:blip>
             <a:stretch>
-              <a:fillRect l="0" t="0" r="0" b="0"/>
+              <a:fillRect/>
             </a:stretch>
           </a:blipFill>
         </p:spPr>
-      </p:sp>
-      <p:sp>
-        <p:nvSpPr>
-          <p:cNvPr name="Freeform 7" id="7"/>
+        <p:txBody>
+          <a:bodyPr/>
+          <a:lstStyle/>
+          <a:p>
+            <a:endParaRPr lang="en-US"/>
+          </a:p>
+        </p:txBody>
+      </p:sp>
+      <p:sp>
+        <p:nvSpPr>
+          <p:cNvPr id="7" name="Freeform 7"/>
           <p:cNvSpPr/>
           <p:nvPr/>
         </p:nvSpPr>
         <p:spPr>
-          <a:xfrm flipH="false" flipV="false" rot="0">
+          <a:xfrm>
             <a:off x="572274" y="2590655"/>
             <a:ext cx="7635336" cy="4485760"/>
           </a:xfrm>
@@ -5990,9 +6298,9 @@
             <a:gdLst/>
             <a:ahLst/>
             <a:cxnLst/>
-            <a:rect r="r" b="b" t="t" l="l"/>
+            <a:rect l="l" t="t" r="r" b="b"/>
             <a:pathLst>
-              <a:path h="4485760" w="7635336">
+              <a:path w="7635336" h="4485760">
                 <a:moveTo>
                   <a:pt x="0" y="0"/>
                 </a:moveTo>
@@ -6004,6 +6312,59 @@
                 </a:lnTo>
                 <a:lnTo>
                   <a:pt x="0" y="4485760"/>
+                </a:lnTo>
+                <a:lnTo>
+                  <a:pt x="0" y="0"/>
+                </a:lnTo>
+                <a:close/>
+              </a:path>
+            </a:pathLst>
+          </a:custGeom>
+          <a:blipFill>
+            <a:blip r:embed="rId3"/>
+            <a:stretch>
+              <a:fillRect/>
+            </a:stretch>
+          </a:blipFill>
+        </p:spPr>
+        <p:txBody>
+          <a:bodyPr/>
+          <a:lstStyle/>
+          <a:p>
+            <a:endParaRPr lang="en-US"/>
+          </a:p>
+        </p:txBody>
+      </p:sp>
+      <p:sp>
+        <p:nvSpPr>
+          <p:cNvPr id="8" name="Freeform 8"/>
+          <p:cNvSpPr/>
+          <p:nvPr/>
+        </p:nvSpPr>
+        <p:spPr>
+          <a:xfrm>
+            <a:off x="6719289" y="1028700"/>
+            <a:ext cx="11301259" cy="1949467"/>
+          </a:xfrm>
+          <a:custGeom>
+            <a:avLst/>
+            <a:gdLst/>
+            <a:ahLst/>
+            <a:cxnLst/>
+            <a:rect l="l" t="t" r="r" b="b"/>
+            <a:pathLst>
+              <a:path w="11301259" h="1949467">
+                <a:moveTo>
+                  <a:pt x="0" y="0"/>
+                </a:moveTo>
+                <a:lnTo>
+                  <a:pt x="11301259" y="0"/>
+                </a:lnTo>
+                <a:lnTo>
+                  <a:pt x="11301259" y="1949467"/>
+                </a:lnTo>
+                <a:lnTo>
+                  <a:pt x="0" y="1949467"/>
                 </a:lnTo>
                 <a:lnTo>
                   <a:pt x="0" y="0"/>
@@ -6015,30 +6376,37 @@
           <a:blipFill>
             <a:blip r:embed="rId4"/>
             <a:stretch>
-              <a:fillRect l="0" t="0" r="0" b="0"/>
+              <a:fillRect/>
             </a:stretch>
           </a:blipFill>
         </p:spPr>
-      </p:sp>
-      <p:sp>
-        <p:nvSpPr>
-          <p:cNvPr name="Freeform 8" id="8"/>
+        <p:txBody>
+          <a:bodyPr/>
+          <a:lstStyle/>
+          <a:p>
+            <a:endParaRPr lang="en-US"/>
+          </a:p>
+        </p:txBody>
+      </p:sp>
+      <p:sp>
+        <p:nvSpPr>
+          <p:cNvPr id="9" name="Freeform 9"/>
           <p:cNvSpPr/>
           <p:nvPr/>
         </p:nvSpPr>
         <p:spPr>
-          <a:xfrm flipH="false" flipV="false" rot="0">
-            <a:off x="6719289" y="1028700"/>
-            <a:ext cx="11301259" cy="1949467"/>
+          <a:xfrm>
+            <a:off x="6719289" y="6856782"/>
+            <a:ext cx="11301259" cy="2401518"/>
           </a:xfrm>
           <a:custGeom>
             <a:avLst/>
             <a:gdLst/>
             <a:ahLst/>
             <a:cxnLst/>
-            <a:rect r="r" b="b" t="t" l="l"/>
+            <a:rect l="l" t="t" r="r" b="b"/>
             <a:pathLst>
-              <a:path h="1949467" w="11301259">
+              <a:path w="11301259" h="2401518">
                 <a:moveTo>
                   <a:pt x="0" y="0"/>
                 </a:moveTo>
@@ -6046,10 +6414,10 @@
                   <a:pt x="11301259" y="0"/>
                 </a:lnTo>
                 <a:lnTo>
-                  <a:pt x="11301259" y="1949467"/>
-                </a:lnTo>
-                <a:lnTo>
-                  <a:pt x="0" y="1949467"/>
+                  <a:pt x="11301259" y="2401518"/>
+                </a:lnTo>
+                <a:lnTo>
+                  <a:pt x="0" y="2401518"/>
                 </a:lnTo>
                 <a:lnTo>
                   <a:pt x="0" y="0"/>
@@ -6061,56 +6429,17 @@
           <a:blipFill>
             <a:blip r:embed="rId5"/>
             <a:stretch>
-              <a:fillRect l="0" t="0" r="0" b="0"/>
+              <a:fillRect/>
             </a:stretch>
           </a:blipFill>
         </p:spPr>
-      </p:sp>
-      <p:sp>
-        <p:nvSpPr>
-          <p:cNvPr name="Freeform 9" id="9"/>
-          <p:cNvSpPr/>
-          <p:nvPr/>
-        </p:nvSpPr>
-        <p:spPr>
-          <a:xfrm flipH="false" flipV="false" rot="0">
-            <a:off x="6719289" y="6856782"/>
-            <a:ext cx="11301259" cy="2401518"/>
-          </a:xfrm>
-          <a:custGeom>
-            <a:avLst/>
-            <a:gdLst/>
-            <a:ahLst/>
-            <a:cxnLst/>
-            <a:rect r="r" b="b" t="t" l="l"/>
-            <a:pathLst>
-              <a:path h="2401518" w="11301259">
-                <a:moveTo>
-                  <a:pt x="0" y="0"/>
-                </a:moveTo>
-                <a:lnTo>
-                  <a:pt x="11301259" y="0"/>
-                </a:lnTo>
-                <a:lnTo>
-                  <a:pt x="11301259" y="2401518"/>
-                </a:lnTo>
-                <a:lnTo>
-                  <a:pt x="0" y="2401518"/>
-                </a:lnTo>
-                <a:lnTo>
-                  <a:pt x="0" y="0"/>
-                </a:lnTo>
-                <a:close/>
-              </a:path>
-            </a:pathLst>
-          </a:custGeom>
-          <a:blipFill>
-            <a:blip r:embed="rId6"/>
-            <a:stretch>
-              <a:fillRect l="0" t="0" r="0" b="0"/>
-            </a:stretch>
-          </a:blipFill>
-        </p:spPr>
+        <p:txBody>
+          <a:bodyPr/>
+          <a:lstStyle/>
+          <a:p>
+            <a:endParaRPr lang="en-US"/>
+          </a:p>
+        </p:txBody>
       </p:sp>
     </p:spTree>
   </p:cSld>
@@ -6121,13 +6450,14 @@
 </file>
 
 <file path=ppt/slides/slide8.xml><?xml version="1.0" encoding="utf-8"?>
-<p:sld xmlns:p="http://schemas.openxmlformats.org/presentationml/2006/main" xmlns:a="http://schemas.openxmlformats.org/drawingml/2006/main" xmlns:r="http://schemas.openxmlformats.org/officeDocument/2006/relationships">
+<p:sld xmlns:a="http://schemas.openxmlformats.org/drawingml/2006/main" xmlns:r="http://schemas.openxmlformats.org/officeDocument/2006/relationships" xmlns:p="http://schemas.openxmlformats.org/presentationml/2006/main">
   <p:cSld>
     <p:bg>
       <p:bgPr>
         <a:solidFill>
           <a:srgbClr val="F6F3E4"/>
         </a:solidFill>
+        <a:effectLst/>
       </p:bgPr>
     </p:bg>
     <p:spTree>
@@ -6146,12 +6476,12 @@
       </p:grpSpPr>
       <p:sp>
         <p:nvSpPr>
-          <p:cNvPr name="TextBox 2" id="2"/>
-          <p:cNvSpPr txBox="true"/>
+          <p:cNvPr id="2" name="TextBox 2"/>
+          <p:cNvSpPr txBox="1"/>
           <p:nvPr/>
         </p:nvSpPr>
         <p:spPr>
-          <a:xfrm rot="0">
+          <a:xfrm>
             <a:off x="4967619" y="3566858"/>
             <a:ext cx="8352763" cy="3000884"/>
           </a:xfrm>
@@ -6160,7 +6490,7 @@
           </a:prstGeom>
         </p:spPr>
         <p:txBody>
-          <a:bodyPr anchor="t" rtlCol="false" tIns="0" lIns="0" bIns="0" rIns="0">
+          <a:bodyPr lIns="0" tIns="0" rIns="0" bIns="0" rtlCol="0" anchor="t">
             <a:spAutoFit/>
           </a:bodyPr>
           <a:lstStyle/>
@@ -6206,12 +6536,12 @@
       </p:sp>
       <p:sp>
         <p:nvSpPr>
-          <p:cNvPr name="Freeform 3" id="3"/>
+          <p:cNvPr id="3" name="Freeform 3"/>
           <p:cNvSpPr/>
           <p:nvPr/>
         </p:nvSpPr>
         <p:spPr>
-          <a:xfrm flipH="true" flipV="false" rot="0">
+          <a:xfrm flipH="1">
             <a:off x="13854371" y="5755552"/>
             <a:ext cx="1726413" cy="1318548"/>
           </a:xfrm>
@@ -6220,9 +6550,9 @@
             <a:gdLst/>
             <a:ahLst/>
             <a:cxnLst/>
-            <a:rect r="r" b="b" t="t" l="l"/>
+            <a:rect l="l" t="t" r="r" b="b"/>
             <a:pathLst>
-              <a:path h="1318548" w="1726413">
+              <a:path w="1726413" h="1318548">
                 <a:moveTo>
                   <a:pt x="1726413" y="0"/>
                 </a:moveTo>
@@ -6243,27 +6573,34 @@
             </a:pathLst>
           </a:custGeom>
           <a:blipFill>
-            <a:blip r:embed="rId2">
+            <a:blip>
               <a:extLst>
                 <a:ext uri="{96DAC541-7B7A-43D3-8B79-37D633B846F1}">
-                  <asvg:svgBlip xmlns:asvg="http://schemas.microsoft.com/office/drawing/2016/SVG/main" r:embed="rId3"/>
+                  <asvg:svgBlip xmlns:asvg="http://schemas.microsoft.com/office/drawing/2016/SVG/main" r:embed="rId2"/>
                 </a:ext>
               </a:extLst>
             </a:blip>
             <a:stretch>
-              <a:fillRect l="0" t="0" r="0" b="0"/>
+              <a:fillRect/>
             </a:stretch>
           </a:blipFill>
         </p:spPr>
-      </p:sp>
-      <p:sp>
-        <p:nvSpPr>
-          <p:cNvPr name="Freeform 4" id="4"/>
+        <p:txBody>
+          <a:bodyPr/>
+          <a:lstStyle/>
+          <a:p>
+            <a:endParaRPr lang="en-US"/>
+          </a:p>
+        </p:txBody>
+      </p:sp>
+      <p:sp>
+        <p:nvSpPr>
+          <p:cNvPr id="4" name="Freeform 4"/>
           <p:cNvSpPr/>
           <p:nvPr/>
         </p:nvSpPr>
         <p:spPr>
-          <a:xfrm flipH="false" flipV="false" rot="0">
+          <a:xfrm>
             <a:off x="3418501" y="1900608"/>
             <a:ext cx="1648591" cy="1259111"/>
           </a:xfrm>
@@ -6272,9 +6609,9 @@
             <a:gdLst/>
             <a:ahLst/>
             <a:cxnLst/>
-            <a:rect r="r" b="b" t="t" l="l"/>
+            <a:rect l="l" t="t" r="r" b="b"/>
             <a:pathLst>
-              <a:path h="1259111" w="1648591">
+              <a:path w="1648591" h="1259111">
                 <a:moveTo>
                   <a:pt x="0" y="0"/>
                 </a:moveTo>
@@ -6295,27 +6632,34 @@
             </a:pathLst>
           </a:custGeom>
           <a:blipFill>
-            <a:blip r:embed="rId2">
+            <a:blip>
               <a:extLst>
                 <a:ext uri="{96DAC541-7B7A-43D3-8B79-37D633B846F1}">
-                  <asvg:svgBlip xmlns:asvg="http://schemas.microsoft.com/office/drawing/2016/SVG/main" r:embed="rId3"/>
+                  <asvg:svgBlip xmlns:asvg="http://schemas.microsoft.com/office/drawing/2016/SVG/main" r:embed="rId2"/>
                 </a:ext>
               </a:extLst>
             </a:blip>
             <a:stretch>
-              <a:fillRect l="0" t="0" r="0" b="0"/>
+              <a:fillRect/>
             </a:stretch>
           </a:blipFill>
         </p:spPr>
-      </p:sp>
-      <p:sp>
-        <p:nvSpPr>
-          <p:cNvPr name="Freeform 5" id="5"/>
+        <p:txBody>
+          <a:bodyPr/>
+          <a:lstStyle/>
+          <a:p>
+            <a:endParaRPr lang="en-US"/>
+          </a:p>
+        </p:txBody>
+      </p:sp>
+      <p:sp>
+        <p:nvSpPr>
+          <p:cNvPr id="5" name="Freeform 5"/>
           <p:cNvSpPr/>
           <p:nvPr/>
         </p:nvSpPr>
         <p:spPr>
-          <a:xfrm flipH="false" flipV="false" rot="2589396">
+          <a:xfrm rot="2589396">
             <a:off x="-900555" y="1971844"/>
             <a:ext cx="2605102" cy="3345235"/>
           </a:xfrm>
@@ -6324,9 +6668,9 @@
             <a:gdLst/>
             <a:ahLst/>
             <a:cxnLst/>
-            <a:rect r="r" b="b" t="t" l="l"/>
+            <a:rect l="l" t="t" r="r" b="b"/>
             <a:pathLst>
-              <a:path h="3345235" w="2605102">
+              <a:path w="2605102" h="3345235">
                 <a:moveTo>
                   <a:pt x="0" y="0"/>
                 </a:moveTo>
@@ -6338,6 +6682,59 @@
                 </a:lnTo>
                 <a:lnTo>
                   <a:pt x="0" y="3345235"/>
+                </a:lnTo>
+                <a:lnTo>
+                  <a:pt x="0" y="0"/>
+                </a:lnTo>
+                <a:close/>
+              </a:path>
+            </a:pathLst>
+          </a:custGeom>
+          <a:blipFill>
+            <a:blip r:embed="rId3"/>
+            <a:stretch>
+              <a:fillRect/>
+            </a:stretch>
+          </a:blipFill>
+        </p:spPr>
+        <p:txBody>
+          <a:bodyPr/>
+          <a:lstStyle/>
+          <a:p>
+            <a:endParaRPr lang="en-US"/>
+          </a:p>
+        </p:txBody>
+      </p:sp>
+      <p:sp>
+        <p:nvSpPr>
+          <p:cNvPr id="6" name="Freeform 6"/>
+          <p:cNvSpPr/>
+          <p:nvPr/>
+        </p:nvSpPr>
+        <p:spPr>
+          <a:xfrm>
+            <a:off x="13874648" y="6868216"/>
+            <a:ext cx="5644997" cy="2878949"/>
+          </a:xfrm>
+          <a:custGeom>
+            <a:avLst/>
+            <a:gdLst/>
+            <a:ahLst/>
+            <a:cxnLst/>
+            <a:rect l="l" t="t" r="r" b="b"/>
+            <a:pathLst>
+              <a:path w="5644997" h="2878949">
+                <a:moveTo>
+                  <a:pt x="0" y="0"/>
+                </a:moveTo>
+                <a:lnTo>
+                  <a:pt x="5644997" y="0"/>
+                </a:lnTo>
+                <a:lnTo>
+                  <a:pt x="5644997" y="2878949"/>
+                </a:lnTo>
+                <a:lnTo>
+                  <a:pt x="0" y="2878949"/>
                 </a:lnTo>
                 <a:lnTo>
                   <a:pt x="0" y="0"/>
@@ -6349,41 +6746,48 @@
           <a:blipFill>
             <a:blip r:embed="rId4"/>
             <a:stretch>
-              <a:fillRect l="0" t="0" r="0" b="0"/>
+              <a:fillRect/>
             </a:stretch>
           </a:blipFill>
         </p:spPr>
-      </p:sp>
-      <p:sp>
-        <p:nvSpPr>
-          <p:cNvPr name="Freeform 6" id="6"/>
+        <p:txBody>
+          <a:bodyPr/>
+          <a:lstStyle/>
+          <a:p>
+            <a:endParaRPr lang="en-US"/>
+          </a:p>
+        </p:txBody>
+      </p:sp>
+      <p:sp>
+        <p:nvSpPr>
+          <p:cNvPr id="7" name="Freeform 7"/>
           <p:cNvSpPr/>
           <p:nvPr/>
         </p:nvSpPr>
         <p:spPr>
-          <a:xfrm flipH="false" flipV="false" rot="0">
-            <a:off x="13874648" y="6868216"/>
-            <a:ext cx="5644997" cy="2878949"/>
+          <a:xfrm>
+            <a:off x="1362551" y="7074100"/>
+            <a:ext cx="3453671" cy="4780167"/>
           </a:xfrm>
           <a:custGeom>
             <a:avLst/>
             <a:gdLst/>
             <a:ahLst/>
             <a:cxnLst/>
-            <a:rect r="r" b="b" t="t" l="l"/>
+            <a:rect l="l" t="t" r="r" b="b"/>
             <a:pathLst>
-              <a:path h="2878949" w="5644997">
+              <a:path w="3453671" h="4780167">
                 <a:moveTo>
                   <a:pt x="0" y="0"/>
                 </a:moveTo>
                 <a:lnTo>
-                  <a:pt x="5644997" y="0"/>
-                </a:lnTo>
-                <a:lnTo>
-                  <a:pt x="5644997" y="2878949"/>
-                </a:lnTo>
-                <a:lnTo>
-                  <a:pt x="0" y="2878949"/>
+                  <a:pt x="3453671" y="0"/>
+                </a:lnTo>
+                <a:lnTo>
+                  <a:pt x="3453671" y="4780167"/>
+                </a:lnTo>
+                <a:lnTo>
+                  <a:pt x="0" y="4780167"/>
                 </a:lnTo>
                 <a:lnTo>
                   <a:pt x="0" y="0"/>
@@ -6395,41 +6799,48 @@
           <a:blipFill>
             <a:blip r:embed="rId5"/>
             <a:stretch>
-              <a:fillRect l="0" t="0" r="0" b="0"/>
+              <a:fillRect/>
             </a:stretch>
           </a:blipFill>
         </p:spPr>
-      </p:sp>
-      <p:sp>
-        <p:nvSpPr>
-          <p:cNvPr name="Freeform 7" id="7"/>
+        <p:txBody>
+          <a:bodyPr/>
+          <a:lstStyle/>
+          <a:p>
+            <a:endParaRPr lang="en-US"/>
+          </a:p>
+        </p:txBody>
+      </p:sp>
+      <p:sp>
+        <p:nvSpPr>
+          <p:cNvPr id="8" name="Freeform 8"/>
           <p:cNvSpPr/>
           <p:nvPr/>
         </p:nvSpPr>
         <p:spPr>
-          <a:xfrm flipH="false" flipV="false" rot="0">
-            <a:off x="1362551" y="7074100"/>
-            <a:ext cx="3453671" cy="4780167"/>
+          <a:xfrm>
+            <a:off x="13129385" y="-571642"/>
+            <a:ext cx="4129915" cy="3200684"/>
           </a:xfrm>
           <a:custGeom>
             <a:avLst/>
             <a:gdLst/>
             <a:ahLst/>
             <a:cxnLst/>
-            <a:rect r="r" b="b" t="t" l="l"/>
+            <a:rect l="l" t="t" r="r" b="b"/>
             <a:pathLst>
-              <a:path h="4780167" w="3453671">
+              <a:path w="4129915" h="3200684">
                 <a:moveTo>
                   <a:pt x="0" y="0"/>
                 </a:moveTo>
                 <a:lnTo>
-                  <a:pt x="3453671" y="0"/>
-                </a:lnTo>
-                <a:lnTo>
-                  <a:pt x="3453671" y="4780167"/>
-                </a:lnTo>
-                <a:lnTo>
-                  <a:pt x="0" y="4780167"/>
+                  <a:pt x="4129915" y="0"/>
+                </a:lnTo>
+                <a:lnTo>
+                  <a:pt x="4129915" y="3200684"/>
+                </a:lnTo>
+                <a:lnTo>
+                  <a:pt x="0" y="3200684"/>
                 </a:lnTo>
                 <a:lnTo>
                   <a:pt x="0" y="0"/>
@@ -6441,56 +6852,17 @@
           <a:blipFill>
             <a:blip r:embed="rId6"/>
             <a:stretch>
-              <a:fillRect l="0" t="0" r="0" b="0"/>
+              <a:fillRect/>
             </a:stretch>
           </a:blipFill>
         </p:spPr>
-      </p:sp>
-      <p:sp>
-        <p:nvSpPr>
-          <p:cNvPr name="Freeform 8" id="8"/>
-          <p:cNvSpPr/>
-          <p:nvPr/>
-        </p:nvSpPr>
-        <p:spPr>
-          <a:xfrm flipH="false" flipV="false" rot="0">
-            <a:off x="13129385" y="-571642"/>
-            <a:ext cx="4129915" cy="3200684"/>
-          </a:xfrm>
-          <a:custGeom>
-            <a:avLst/>
-            <a:gdLst/>
-            <a:ahLst/>
-            <a:cxnLst/>
-            <a:rect r="r" b="b" t="t" l="l"/>
-            <a:pathLst>
-              <a:path h="3200684" w="4129915">
-                <a:moveTo>
-                  <a:pt x="0" y="0"/>
-                </a:moveTo>
-                <a:lnTo>
-                  <a:pt x="4129915" y="0"/>
-                </a:lnTo>
-                <a:lnTo>
-                  <a:pt x="4129915" y="3200684"/>
-                </a:lnTo>
-                <a:lnTo>
-                  <a:pt x="0" y="3200684"/>
-                </a:lnTo>
-                <a:lnTo>
-                  <a:pt x="0" y="0"/>
-                </a:lnTo>
-                <a:close/>
-              </a:path>
-            </a:pathLst>
-          </a:custGeom>
-          <a:blipFill>
-            <a:blip r:embed="rId7"/>
-            <a:stretch>
-              <a:fillRect l="0" t="0" r="0" b="0"/>
-            </a:stretch>
-          </a:blipFill>
-        </p:spPr>
+        <p:txBody>
+          <a:bodyPr/>
+          <a:lstStyle/>
+          <a:p>
+            <a:endParaRPr lang="en-US"/>
+          </a:p>
+        </p:txBody>
       </p:sp>
     </p:spTree>
   </p:cSld>

</xml_diff>